<commit_message>
add pagenumbering and small corrections
</commit_message>
<xml_diff>
--- a/2020-06-01.pptx
+++ b/2020-06-01.pptx
@@ -4179,7 +4179,7 @@
                       </a:pPr>
                       <a:r>
                         <a:rPr/>
-                        <a:t>Accéssibilité</a:t>
+                        <a:t>Accessibilité</a:t>
                       </a:r>
                     </a:p>
                   </a:txBody>
@@ -4341,7 +4341,7 @@
                       </a:r>
                       <a:r>
                         <a:rPr/>
-                        <a:t>maker</a:t>
+                        <a:t>«maker»</a:t>
                       </a:r>
                     </a:p>
                   </a:txBody>
@@ -4640,7 +4640,7 @@
             </a:pPr>
             <a:r>
               <a:rPr/>
-              <a:t>pourraient bénéficier d’une collaboration dans Sfere au délà de l’ADEF, par exemple avec l’I2M et l’IREM de Marseille.</a:t>
+              <a:t>pourraient bénéficier d’une collaboration dans Sfere au-delà de l’ADEF, par exemple avec l’I2M et l’IREM de Marseille.</a:t>
             </a:r>
           </a:p>
         </p:txBody>
@@ -5774,7 +5774,7 @@
             </a:pPr>
             <a:r>
               <a:rPr/>
-              <a:t>Je suis maker.</a:t>
+              <a:t>Je suis une «maker».</a:t>
             </a:r>
           </a:p>
           <a:p>

</xml_diff>

<commit_message>
improve picture placement in the research part, and some other corrections
</commit_message>
<xml_diff>
--- a/2020-06-01.pptx
+++ b/2020-06-01.pptx
@@ -31,6 +31,7 @@
     <p:sldId id="279" r:id="rId25"/>
     <p:sldId id="280" r:id="rId26"/>
     <p:sldId id="281" r:id="rId27"/>
+    <p:sldId id="282" r:id="rId28"/>
   </p:sldIdLst>
   <p:sldSz cx="9144000" cy="6858000" type="screen4x3"/>
   <p:notesSz cx="6858000" cy="9144000"/>
@@ -3327,47 +3328,6 @@
       </p:grpSpPr>
       <p:sp>
         <p:nvSpPr>
-          <p:cNvPr id="2" name="Title 1"/>
-          <p:cNvSpPr>
-            <a:spLocks noGrp="1"/>
-          </p:cNvSpPr>
-          <p:nvPr>
-            <p:ph type="title"/>
-          </p:nvPr>
-        </p:nvSpPr>
-        <p:spPr/>
-        <p:txBody>
-          <a:bodyPr/>
-          <a:lstStyle/>
-          <a:p>
-            <a:pPr lvl="0" marL="0" indent="0">
-              <a:buNone/>
-            </a:pPr>
-            <a:r>
-              <a:rPr/>
-              <a:t>Intégration</a:t>
-            </a:r>
-            <a:r>
-              <a:rPr/>
-              <a:t> </a:t>
-            </a:r>
-            <a:r>
-              <a:rPr/>
-              <a:t>à</a:t>
-            </a:r>
-            <a:r>
-              <a:rPr/>
-              <a:t> </a:t>
-            </a:r>
-            <a:r>
-              <a:rPr/>
-              <a:t>l’Inspé</a:t>
-            </a:r>
-          </a:p>
-        </p:txBody>
-      </p:sp>
-      <p:sp>
-        <p:nvSpPr>
           <p:cNvPr id="3" name="Content Placeholder 2"/>
           <p:cNvSpPr>
             <a:spLocks noGrp="1"/>
@@ -3389,42 +3349,7 @@
             </a:pPr>
             <a:r>
               <a:rPr b="1"/>
-              <a:t>Motivée par les questions éducatives</a:t>
-            </a:r>
-          </a:p>
-          <a:p>
-            <a:pPr lvl="1"/>
-            <a:r>
-              <a:rPr/>
-              <a:t>suivi deux MOOC sur l’éducation</a:t>
-            </a:r>
-          </a:p>
-          <a:p>
-            <a:pPr lvl="2"/>
-            <a:r>
-              <a:rPr/>
-              <a:t>eFan Maths session 2 (ESPÉ de Lyon et autres partenaires)</a:t>
-            </a:r>
-          </a:p>
-          <a:p>
-            <a:pPr lvl="3"/>
-            <a:r>
-              <a:rPr/>
-              <a:t>projet «Objets mathématiques imprimés en 3D»</a:t>
-            </a:r>
-          </a:p>
-          <a:p>
-            <a:pPr lvl="2"/>
-            <a:r>
-              <a:rPr/>
-              <a:t>Design and Development of Educational Technology (MIT)</a:t>
-            </a:r>
-          </a:p>
-          <a:p>
-            <a:pPr lvl="3"/>
-            <a:r>
-              <a:rPr/>
-              <a:t>projet «Plagiarism prevention»</a:t>
+              <a:t>Mes compétences et les thématiques de l’ADEF</a:t>
             </a:r>
           </a:p>
         </p:txBody>
@@ -3435,6 +3360,132 @@
 </file>
 
 <file path=ppt/slides/slide11.xml><?xml version="1.0" encoding="utf-8"?>
+<p:sld xmlns:a="http://schemas.openxmlformats.org/drawingml/2006/main" xmlns:r="http://schemas.openxmlformats.org/officeDocument/2006/relationships" xmlns:p="http://schemas.openxmlformats.org/presentationml/2006/main">
+  <p:cSld>
+    <p:spTree>
+      <p:nvGrpSpPr>
+        <p:cNvPr id="1" name=""/>
+        <p:cNvGrpSpPr/>
+        <p:nvPr/>
+      </p:nvGrpSpPr>
+      <p:grpSpPr>
+        <a:xfrm>
+          <a:off x="0" y="0"/>
+          <a:ext cx="0" cy="0"/>
+          <a:chOff x="0" y="0"/>
+          <a:chExt cx="0" cy="0"/>
+        </a:xfrm>
+      </p:grpSpPr>
+      <p:sp>
+        <p:nvSpPr>
+          <p:cNvPr id="2" name="Title 1"/>
+          <p:cNvSpPr>
+            <a:spLocks noGrp="1"/>
+          </p:cNvSpPr>
+          <p:nvPr>
+            <p:ph type="title"/>
+          </p:nvPr>
+        </p:nvSpPr>
+        <p:spPr/>
+        <p:txBody>
+          <a:bodyPr/>
+          <a:lstStyle/>
+          <a:p>
+            <a:pPr lvl="0" marL="0" indent="0">
+              <a:buNone/>
+            </a:pPr>
+            <a:r>
+              <a:rPr/>
+              <a:t>Intégration</a:t>
+            </a:r>
+            <a:r>
+              <a:rPr/>
+              <a:t> </a:t>
+            </a:r>
+            <a:r>
+              <a:rPr/>
+              <a:t>à</a:t>
+            </a:r>
+            <a:r>
+              <a:rPr/>
+              <a:t> </a:t>
+            </a:r>
+            <a:r>
+              <a:rPr/>
+              <a:t>l’Inspé</a:t>
+            </a:r>
+          </a:p>
+        </p:txBody>
+      </p:sp>
+      <p:sp>
+        <p:nvSpPr>
+          <p:cNvPr id="3" name="Content Placeholder 2"/>
+          <p:cNvSpPr>
+            <a:spLocks noGrp="1"/>
+          </p:cNvSpPr>
+          <p:nvPr>
+            <p:ph idx="1"/>
+          </p:nvPr>
+        </p:nvSpPr>
+        <p:spPr/>
+        <p:txBody>
+          <a:bodyPr/>
+          <a:lstStyle/>
+          <a:p>
+            <a:pPr lvl="0" marL="0" indent="0">
+              <a:spcBef>
+                <a:spcPts val="3000"/>
+              </a:spcBef>
+              <a:buNone/>
+            </a:pPr>
+            <a:r>
+              <a:rPr b="1"/>
+              <a:t>Motivée par les questions éducatives</a:t>
+            </a:r>
+          </a:p>
+          <a:p>
+            <a:pPr lvl="1"/>
+            <a:r>
+              <a:rPr/>
+              <a:t>suivi deux MOOC sur l’éducation</a:t>
+            </a:r>
+          </a:p>
+          <a:p>
+            <a:pPr lvl="2"/>
+            <a:r>
+              <a:rPr/>
+              <a:t>eFan Maths session 2 (ESPÉ de Lyon et autres partenaires)</a:t>
+            </a:r>
+          </a:p>
+          <a:p>
+            <a:pPr lvl="3"/>
+            <a:r>
+              <a:rPr/>
+              <a:t>projet «Objets mathématiques imprimés en 3D»</a:t>
+            </a:r>
+          </a:p>
+          <a:p>
+            <a:pPr lvl="2"/>
+            <a:r>
+              <a:rPr/>
+              <a:t>Design and Development of Educational Technology (MIT)</a:t>
+            </a:r>
+          </a:p>
+          <a:p>
+            <a:pPr lvl="3"/>
+            <a:r>
+              <a:rPr/>
+              <a:t>projet «Plagiarism prevention»</a:t>
+            </a:r>
+          </a:p>
+        </p:txBody>
+      </p:sp>
+    </p:spTree>
+  </p:cSld>
+</p:sld>
+</file>
+
+<file path=ppt/slides/slide12.xml><?xml version="1.0" encoding="utf-8"?>
 <p:sld xmlns:a="http://schemas.openxmlformats.org/drawingml/2006/main" xmlns:r="http://schemas.openxmlformats.org/officeDocument/2006/relationships" xmlns:p="http://schemas.openxmlformats.org/presentationml/2006/main">
   <p:cSld>
     <p:spTree>
@@ -3486,7 +3537,7 @@
 </p:sld>
 </file>
 
-<file path=ppt/slides/slide12.xml><?xml version="1.0" encoding="utf-8"?>
+<file path=ppt/slides/slide13.xml><?xml version="1.0" encoding="utf-8"?>
 <p:sld xmlns:a="http://schemas.openxmlformats.org/drawingml/2006/main" xmlns:r="http://schemas.openxmlformats.org/officeDocument/2006/relationships" xmlns:p="http://schemas.openxmlformats.org/presentationml/2006/main">
   <p:cSld>
     <p:spTree>
@@ -3559,7 +3610,7 @@
 </p:sld>
 </file>
 
-<file path=ppt/slides/slide13.xml><?xml version="1.0" encoding="utf-8"?>
+<file path=ppt/slides/slide14.xml><?xml version="1.0" encoding="utf-8"?>
 <p:sld xmlns:a="http://schemas.openxmlformats.org/drawingml/2006/main" xmlns:r="http://schemas.openxmlformats.org/officeDocument/2006/relationships" xmlns:p="http://schemas.openxmlformats.org/presentationml/2006/main">
   <p:cSld>
     <p:spTree>
@@ -3725,7 +3776,7 @@
 </p:sld>
 </file>
 
-<file path=ppt/slides/slide14.xml><?xml version="1.0" encoding="utf-8"?>
+<file path=ppt/slides/slide15.xml><?xml version="1.0" encoding="utf-8"?>
 <p:sld xmlns:a="http://schemas.openxmlformats.org/drawingml/2006/main" xmlns:r="http://schemas.openxmlformats.org/officeDocument/2006/relationships" xmlns:p="http://schemas.openxmlformats.org/presentationml/2006/main">
   <p:cSld>
     <p:spTree>
@@ -3883,7 +3934,7 @@
 </p:sld>
 </file>
 
-<file path=ppt/slides/slide15.xml><?xml version="1.0" encoding="utf-8"?>
+<file path=ppt/slides/slide16.xml><?xml version="1.0" encoding="utf-8"?>
 <p:sld xmlns:a="http://schemas.openxmlformats.org/drawingml/2006/main" xmlns:r="http://schemas.openxmlformats.org/officeDocument/2006/relationships" xmlns:p="http://schemas.openxmlformats.org/presentationml/2006/main">
   <p:cSld>
     <p:spTree>
@@ -3933,7 +3984,7 @@
 </p:sld>
 </file>
 
-<file path=ppt/slides/slide16.xml><?xml version="1.0" encoding="utf-8"?>
+<file path=ppt/slides/slide17.xml><?xml version="1.0" encoding="utf-8"?>
 <p:sld xmlns:a="http://schemas.openxmlformats.org/drawingml/2006/main" xmlns:r="http://schemas.openxmlformats.org/officeDocument/2006/relationships" xmlns:p="http://schemas.openxmlformats.org/presentationml/2006/main">
   <p:cSld>
     <p:spTree>
@@ -4452,7 +4503,7 @@
                       </a:r>
                       <a:r>
                         <a:rPr/>
-                        <a:t>évenements,</a:t>
+                        <a:t>événements,</a:t>
                       </a:r>
                       <a:r>
                         <a:rPr/>
@@ -4499,7 +4550,7 @@
 </p:sld>
 </file>
 
-<file path=ppt/slides/slide17.xml><?xml version="1.0" encoding="utf-8"?>
+<file path=ppt/slides/slide18.xml><?xml version="1.0" encoding="utf-8"?>
 <p:sld xmlns:a="http://schemas.openxmlformats.org/drawingml/2006/main" xmlns:r="http://schemas.openxmlformats.org/officeDocument/2006/relationships" xmlns:p="http://schemas.openxmlformats.org/presentationml/2006/main">
   <p:cSld>
     <p:spTree>
@@ -4599,55 +4650,8 @@
 </p:sld>
 </file>
 
-<file path=ppt/slides/slide18.xml><?xml version="1.0" encoding="UTF-8"?>
+<file path=ppt/slides/slide19.xml><?xml version="1.0" encoding="UTF-8"?>
 <p:sld xmlns:a="http://schemas.openxmlformats.org/drawingml/2006/main" xmlns:r="http://schemas.openxmlformats.org/officeDocument/2006/relationships" xmlns:p="http://schemas.openxmlformats.org/presentationml/2006/main"><p:cSld><p:spTree><p:nvGrpSpPr><p:cNvPr id="1" name="" /><p:cNvGrpSpPr /><p:nvPr /></p:nvGrpSpPr><p:grpSpPr><a:xfrm><a:off x="0" y="0" /><a:ext cx="0" cy="0" /><a:chOff x="0" y="0" /><a:chExt cx="0" cy="0" /></a:xfrm></p:grpSpPr><p:graphicFrame><p:nvGraphicFramePr><p:cNvPr id="6" name="Content Placeholder 5" /><p:cNvGraphicFramePr><a:graphicFrameLocks noGrp="1" /></p:cNvGraphicFramePr><p:nvPr><p:ph idx="1" /></p:nvPr></p:nvGraphicFramePr><p:xfrm><a:off x="457200" y="1600200" /><a:ext cx="8229600" cy="4521200" /></p:xfrm><a:graphic><a:graphicData uri="http://schemas.openxmlformats.org/drawingml/2006/table"><a:tbl><a:tblPr firstRow="1" bandRow="1"><a:tableStyleId>{5C22544A-7EE6-4342-B048-85BDC9FD1C3A}</a:tableStyleId></a:tblPr><a:tblGrid><a:gridCol w="4114800" /><a:gridCol w="4114800" /></a:tblGrid><a:tr h="0"><a:tc><a:txBody><a:bodyPr /><a:lstStyle /><a:p><a:pPr lvl="0" marL="0" indent="0" algn="l"><a:buNone /></a:pPr><a:r><a:rPr /><a:t>Primaire</a:t></a:r></a:p></a:txBody></a:tc><a:tc><a:txBody><a:bodyPr /><a:lstStyle /><a:p><a:pPr lvl="0" marL="0" indent="0" algn="l"><a:buNone /></a:pPr><a:r><a:rPr /><a:t>Nombres</a:t></a:r><a:r><a:rPr /><a:t> </a:t></a:r><a:r><a:rPr /><a:t>avec</a:t></a:r><a:r><a:rPr /><a:t> </a:t></a:r><a:r><a:rPr /><a:t>la</a:t></a:r><a:r><a:rPr /><a:t> </a:t></a:r><a:r><a:rPr /><a:t>yupana</a:t></a:r><a:r><a:rPr /><a:t> </a:t></a:r><a:r><a:rPr /><a:t>inca</a:t></a:r></a:p></a:txBody></a:tc></a:tr><a:tr h="0"><a:tc><a:txBody><a:bodyPr /><a:lstStyle /><a:p><a:pPr lvl="0" marL="0" indent="0" algn="l"><a:buNone /></a:pPr><a:r><a:rPr /><a:t>Secondaire</a:t></a:r></a:p></a:txBody></a:tc><a:tc><a:txBody><a:bodyPr /><a:lstStyle /><a:p><a:pPr lvl="0" marL="0" indent="0" algn="l"><a:buNone /></a:pPr><a:r><a:rPr /><a:t>Géométrie</a:t></a:r><a:r><a:rPr /><a:t> </a:t></a:r><a:r><a:rPr /><a:t>avec</a:t></a:r><a:r><a:rPr /><a:t> </a:t></a:r><a:r><a:rPr /><a:t>l’impression</a:t></a:r><a:r><a:rPr /><a:t> </a:t></a:r><a:r><a:rPr /><a:t>3D</a:t></a:r></a:p></a:txBody></a:tc></a:tr><a:tr h="0"><a:tc><a:txBody><a:bodyPr /><a:lstStyle /><a:p><a:pPr lvl="0" marL="0" indent="0" algn="l"><a:buNone /></a:pPr><a:r><a:rPr /><a:t>Supérieur</a:t></a:r></a:p></a:txBody></a:tc><a:tc><a:txBody><a:bodyPr /><a:lstStyle /><a:p><a:pPr lvl="0" marL="0" indent="0" algn="l"><a:buNone /></a:pPr><a:r><a:rPr /><a:t>Le</a:t></a:r><a:r><a:rPr /><a:t> </a:t></a:r><a:r><a:rPr /><a:t>raisonnement</a:t></a:r><a:r><a:rPr /><a:t> </a:t></a:r><a:r><a:rPr /><a:t>mathématique</a:t></a:r><a:r><a:rPr /><a:t> </a:t></a:r><a:r><a:rPr /><a:t>avec</a:t></a:r><a:r><a:rPr /><a:t> </a:t></a:r><a:r><a:rPr /><a:t>L</a:t></a:r><a14:m><m:oMath xmlns:m="http://schemas.openxmlformats.org/officeDocument/2006/math"><m:r><m:t>∃</m:t></m:r><m:r><m:t>∀</m:t></m:r></m:oMath></a14:m><a:r><a:rPr /><a:t>N</a:t></a:r></a:p></a:txBody></a:tc></a:tr></a:tbl></a:graphicData></a:graphic></p:graphicFrame></p:spTree></p:cSld></p:sld>
-</file>
-
-<file path=ppt/slides/slide19.xml><?xml version="1.0" encoding="utf-8"?>
-<p:sld xmlns:a="http://schemas.openxmlformats.org/drawingml/2006/main" xmlns:r="http://schemas.openxmlformats.org/officeDocument/2006/relationships" xmlns:p="http://schemas.openxmlformats.org/presentationml/2006/main">
-  <p:cSld>
-    <p:spTree>
-      <p:nvGrpSpPr>
-        <p:cNvPr id="1" name=""/>
-        <p:cNvGrpSpPr/>
-        <p:nvPr/>
-      </p:nvGrpSpPr>
-      <p:grpSpPr>
-        <a:xfrm>
-          <a:off x="0" y="0"/>
-          <a:ext cx="0" cy="0"/>
-          <a:chOff x="0" y="0"/>
-          <a:chExt cx="0" cy="0"/>
-        </a:xfrm>
-      </p:grpSpPr>
-      <p:sp>
-        <p:nvSpPr>
-          <p:cNvPr id="3" name="Content Placeholder 2"/>
-          <p:cNvSpPr>
-            <a:spLocks noGrp="1"/>
-          </p:cNvSpPr>
-          <p:nvPr>
-            <p:ph idx="1"/>
-          </p:nvPr>
-        </p:nvSpPr>
-        <p:spPr/>
-        <p:txBody>
-          <a:bodyPr/>
-          <a:lstStyle/>
-          <a:p>
-            <a:pPr lvl="0" marL="0" indent="0">
-              <a:buNone/>
-            </a:pPr>
-            <a:r>
-              <a:rPr/>
-              <a:t>pourraient bénéficier d’une collaboration dans Sfere au-delà de l’ADEF, par exemple avec l’I2M et l’IREM de Marseille.</a:t>
-            </a:r>
-          </a:p>
-        </p:txBody>
-      </p:sp>
-    </p:spTree>
-  </p:cSld>
-</p:sld>
 </file>
 
 <file path=ppt/slides/slide2.xml><?xml version="1.0" encoding="utf-8"?>
@@ -4722,6 +4726,24 @@
         <p:txBody>
           <a:bodyPr/>
           <a:lstStyle/>
+          <a:p>
+            <a:pPr lvl="0" marL="0" indent="0">
+              <a:buNone/>
+            </a:pPr>
+            <a:r>
+              <a:rPr/>
+              <a:t>EAST: Rôle des artefacts dans l’efficacité de l’éducation scientifique et technologique</a:t>
+            </a:r>
+          </a:p>
+          <a:p>
+            <a:pPr lvl="0" marL="0" indent="0">
+              <a:buNone/>
+            </a:pPr>
+            <a:r>
+              <a:rPr/>
+              <a:t>Axe thématique «outils et instruments pour l’enseignement».</a:t>
+            </a:r>
+          </a:p>
           <a:p>
             <a:pPr lvl="0" marL="0" indent="0">
               <a:buNone/>
@@ -4771,80 +4793,11 @@
           <a:lstStyle/>
           <a:p>
             <a:pPr lvl="0" marL="0" indent="0">
-              <a:spcBef>
-                <a:spcPts val="3000"/>
-              </a:spcBef>
               <a:buNone/>
             </a:pPr>
             <a:r>
-              <a:rPr b="1"/>
-              <a:t>Colloques et rencontres</a:t>
-            </a:r>
-          </a:p>
-          <a:p>
-            <a:pPr lvl="0" marL="0" indent="0">
-              <a:spcBef>
-                <a:spcPts val="3000"/>
-              </a:spcBef>
-              <a:buNone/>
-            </a:pPr>
-            <a:r>
-              <a:rPr b="1"/>
-              <a:t>Expérience</a:t>
-            </a:r>
-          </a:p>
-          <a:p>
-            <a:pPr lvl="0" marL="0" indent="0">
-              <a:buNone/>
-            </a:pPr>
-            <a:r>
-              <a:rPr/>
-              <a:t>2015: Médiation scientifique et plateformes de partage</a:t>
-            </a:r>
-            <a:br/>
-            <a:r>
-              <a:rPr/>
-              <a:t>2020: Outils logiciels pour les mathématiques et l’illustration</a:t>
-            </a:r>
-          </a:p>
-          <a:p>
-            <a:pPr lvl="0" marL="0" indent="0">
-              <a:spcBef>
-                <a:spcPts val="3000"/>
-              </a:spcBef>
-              <a:buNone/>
-            </a:pPr>
-            <a:r>
-              <a:rPr b="1"/>
-              <a:t>Propositions</a:t>
-            </a:r>
-          </a:p>
-          <a:p>
-            <a:pPr lvl="1"/>
-            <a:r>
-              <a:rPr/>
-              <a:t>Rencontre interrogeant la médiation, ses usages et ses effets</a:t>
-            </a:r>
-          </a:p>
-          <a:p>
-            <a:pPr lvl="2"/>
-            <a:r>
-              <a:rPr/>
-              <a:t>suite du projet 1.3. cartographie de la relation entre l’éducation, la médiation, les expériences artistique et scientifique et le développement de la personne, 2018</a:t>
-            </a:r>
-          </a:p>
-          <a:p>
-            <a:pPr lvl="1"/>
-            <a:r>
-              <a:rPr/>
-              <a:t>Ateliers Software Carpentry</a:t>
-            </a:r>
-          </a:p>
-          <a:p>
-            <a:pPr lvl="2"/>
-            <a:r>
-              <a:rPr/>
-              <a:t>formation à des compétences informatiques pour la recherche.</a:t>
+              <a:rPr/>
+              <a:t>pourraient bénéficier d’une collaboration dans Sfere au-delà de l’ADEF, par exemple avec l’I2M et l’IREM de Marseille.</a:t>
             </a:r>
           </a:p>
         </p:txBody>
@@ -4894,7 +4847,73 @@
             </a:pPr>
             <a:r>
               <a:rPr b="1"/>
-              <a:t>Médiation scientifique</a:t>
+              <a:t>Colloques et rencontres</a:t>
+            </a:r>
+          </a:p>
+          <a:p>
+            <a:pPr lvl="0" marL="0" indent="0">
+              <a:spcBef>
+                <a:spcPts val="3000"/>
+              </a:spcBef>
+              <a:buNone/>
+            </a:pPr>
+            <a:r>
+              <a:rPr b="1"/>
+              <a:t>Expérience</a:t>
+            </a:r>
+          </a:p>
+          <a:p>
+            <a:pPr lvl="0" marL="0" indent="0">
+              <a:buNone/>
+            </a:pPr>
+            <a:r>
+              <a:rPr/>
+              <a:t>2015: Médiation scientifique et plateformes de partage</a:t>
+            </a:r>
+            <a:br/>
+            <a:r>
+              <a:rPr/>
+              <a:t>2020: Outils logiciels pour les mathématiques et l’illustration</a:t>
+            </a:r>
+          </a:p>
+          <a:p>
+            <a:pPr lvl="0" marL="0" indent="0">
+              <a:spcBef>
+                <a:spcPts val="3000"/>
+              </a:spcBef>
+              <a:buNone/>
+            </a:pPr>
+            <a:r>
+              <a:rPr b="1"/>
+              <a:t>Propositions</a:t>
+            </a:r>
+          </a:p>
+          <a:p>
+            <a:pPr lvl="1"/>
+            <a:r>
+              <a:rPr/>
+              <a:t>Rencontre interrogeant la médiation, ses usages et ses effets</a:t>
+            </a:r>
+          </a:p>
+          <a:p>
+            <a:pPr lvl="2"/>
+            <a:r>
+              <a:rPr/>
+              <a:t>suite du projet 1.3. cartographie de la relation entre l’éducation, la médiation, les expériences artistique et scientifique et le développement de la personne, 2018</a:t>
+            </a:r>
+          </a:p>
+          <a:p>
+            <a:pPr lvl="1"/>
+            <a:r>
+              <a:rPr/>
+              <a:t>Ateliers Software Carpentry</a:t>
+            </a:r>
+          </a:p>
+          <a:p>
+            <a:pPr lvl="2"/>
+            <a:r>
+              <a:rPr/>
+              <a:t>formation à des compétences informatiques pour la recherche.</a:t>
             </a:r>
           </a:p>
         </p:txBody>
@@ -4905,6 +4924,56 @@
 </file>
 
 <file path=ppt/slides/slide22.xml><?xml version="1.0" encoding="utf-8"?>
+<p:sld xmlns:a="http://schemas.openxmlformats.org/drawingml/2006/main" xmlns:r="http://schemas.openxmlformats.org/officeDocument/2006/relationships" xmlns:p="http://schemas.openxmlformats.org/presentationml/2006/main">
+  <p:cSld>
+    <p:spTree>
+      <p:nvGrpSpPr>
+        <p:cNvPr id="1" name=""/>
+        <p:cNvGrpSpPr/>
+        <p:nvPr/>
+      </p:nvGrpSpPr>
+      <p:grpSpPr>
+        <a:xfrm>
+          <a:off x="0" y="0"/>
+          <a:ext cx="0" cy="0"/>
+          <a:chOff x="0" y="0"/>
+          <a:chExt cx="0" cy="0"/>
+        </a:xfrm>
+      </p:grpSpPr>
+      <p:sp>
+        <p:nvSpPr>
+          <p:cNvPr id="3" name="Content Placeholder 2"/>
+          <p:cNvSpPr>
+            <a:spLocks noGrp="1"/>
+          </p:cNvSpPr>
+          <p:nvPr>
+            <p:ph idx="1"/>
+          </p:nvPr>
+        </p:nvSpPr>
+        <p:spPr/>
+        <p:txBody>
+          <a:bodyPr/>
+          <a:lstStyle/>
+          <a:p>
+            <a:pPr lvl="0" marL="0" indent="0">
+              <a:spcBef>
+                <a:spcPts val="3000"/>
+              </a:spcBef>
+              <a:buNone/>
+            </a:pPr>
+            <a:r>
+              <a:rPr b="1"/>
+              <a:t>Médiation scientifique</a:t>
+            </a:r>
+          </a:p>
+        </p:txBody>
+      </p:sp>
+    </p:spTree>
+  </p:cSld>
+</p:sld>
+</file>
+
+<file path=ppt/slides/slide23.xml><?xml version="1.0" encoding="utf-8"?>
 <p:sld xmlns:a="http://schemas.openxmlformats.org/drawingml/2006/main" xmlns:r="http://schemas.openxmlformats.org/officeDocument/2006/relationships" xmlns:p="http://schemas.openxmlformats.org/presentationml/2006/main">
   <p:cSld>
     <p:spTree>
@@ -4956,7 +5025,7 @@
 </p:sld>
 </file>
 
-<file path=ppt/slides/slide23.xml><?xml version="1.0" encoding="utf-8"?>
+<file path=ppt/slides/slide24.xml><?xml version="1.0" encoding="utf-8"?>
 <p:sld xmlns:a="http://schemas.openxmlformats.org/drawingml/2006/main" xmlns:r="http://schemas.openxmlformats.org/officeDocument/2006/relationships" xmlns:p="http://schemas.openxmlformats.org/presentationml/2006/main">
   <p:cSld>
     <p:spTree>
@@ -5008,7 +5077,7 @@
 </p:sld>
 </file>
 
-<file path=ppt/slides/slide24.xml><?xml version="1.0" encoding="utf-8"?>
+<file path=ppt/slides/slide25.xml><?xml version="1.0" encoding="utf-8"?>
 <p:sld xmlns:a="http://schemas.openxmlformats.org/drawingml/2006/main" xmlns:r="http://schemas.openxmlformats.org/officeDocument/2006/relationships" xmlns:p="http://schemas.openxmlformats.org/presentationml/2006/main">
   <p:cSld>
     <p:spTree>
@@ -5314,7 +5383,7 @@
 </p:sld>
 </file>
 
-<file path=ppt/slides/slide25.xml><?xml version="1.0" encoding="utf-8"?>
+<file path=ppt/slides/slide26.xml><?xml version="1.0" encoding="utf-8"?>
 <p:sld xmlns:a="http://schemas.openxmlformats.org/drawingml/2006/main" xmlns:r="http://schemas.openxmlformats.org/officeDocument/2006/relationships" xmlns:p="http://schemas.openxmlformats.org/presentationml/2006/main">
   <p:cSld>
     <p:spTree>
@@ -5361,7 +5430,7 @@
 </p:sld>
 </file>
 
-<file path=ppt/slides/slide26.xml><?xml version="1.0" encoding="utf-8"?>
+<file path=ppt/slides/slide27.xml><?xml version="1.0" encoding="utf-8"?>
 <p:sld xmlns:a="http://schemas.openxmlformats.org/drawingml/2006/main" xmlns:r="http://schemas.openxmlformats.org/officeDocument/2006/relationships" xmlns:p="http://schemas.openxmlformats.org/presentationml/2006/main">
   <p:cSld>
     <p:spTree>
@@ -5450,20 +5519,28 @@
           <a:lstStyle/>
           <a:p>
             <a:pPr lvl="0" marL="0" indent="0">
+              <a:spcBef>
+                <a:spcPts val="3000"/>
+              </a:spcBef>
               <a:buNone/>
             </a:pPr>
             <a:r>
-              <a:rPr/>
-              <a:t>EAST: Rôle des artefacts dans l’efficacité de l’éducation scientifique et technologique</a:t>
+              <a:rPr b="1"/>
+              <a:t>Yupana Inca</a:t>
             </a:r>
           </a:p>
           <a:p>
             <a:pPr lvl="0" marL="0" indent="0">
               <a:buNone/>
             </a:pPr>
-            <a:r>
-              <a:rPr/>
-              <a:t>Axe thématique «outils et instruments pour l’enseignement».</a:t>
+          </a:p>
+          <a:p>
+            <a:pPr lvl="0" marL="0" indent="0">
+              <a:buNone/>
+            </a:pPr>
+            <a:r>
+              <a:rPr/>
+              <a:t>Expérience d’initiation à l’addition et à la multiplication</a:t>
             </a:r>
           </a:p>
         </p:txBody>
@@ -5513,7 +5590,7 @@
             </a:pPr>
             <a:r>
               <a:rPr b="1"/>
-              <a:t>Yupana Inca</a:t>
+              <a:t>L’impression 3D</a:t>
             </a:r>
           </a:p>
           <a:p>
@@ -5527,7 +5604,7 @@
             </a:pPr>
             <a:r>
               <a:rPr/>
-              <a:t>Expérience d’initiation à l’addition et à la multiplication</a:t>
+              <a:t>Vecteur de compréhension de la géométrie.</a:t>
             </a:r>
           </a:p>
         </p:txBody>
@@ -5580,20 +5657,6 @@
               <a:t>L’impression 3D</a:t>
             </a:r>
           </a:p>
-          <a:p>
-            <a:pPr lvl="0" marL="0" indent="0">
-              <a:buNone/>
-            </a:pPr>
-          </a:p>
-          <a:p>
-            <a:pPr lvl="0" marL="0" indent="0">
-              <a:buNone/>
-            </a:pPr>
-            <a:r>
-              <a:rPr/>
-              <a:t>Vecteur de compréhension de la géométrie.</a:t>
-            </a:r>
-          </a:p>
         </p:txBody>
       </p:sp>
     </p:spTree>
@@ -5602,6 +5665,105 @@
 </file>
 
 <file path=ppt/slides/slide7.xml><?xml version="1.0" encoding="utf-8"?>
+<p:sld xmlns:a="http://schemas.openxmlformats.org/drawingml/2006/main" xmlns:r="http://schemas.openxmlformats.org/officeDocument/2006/relationships" xmlns:p="http://schemas.openxmlformats.org/presentationml/2006/main">
+  <p:cSld>
+    <p:spTree>
+      <p:nvGrpSpPr>
+        <p:cNvPr id="1" name=""/>
+        <p:cNvGrpSpPr/>
+        <p:nvPr/>
+      </p:nvGrpSpPr>
+      <p:grpSpPr>
+        <a:xfrm>
+          <a:off x="0" y="0"/>
+          <a:ext cx="0" cy="0"/>
+          <a:chOff x="0" y="0"/>
+          <a:chExt cx="0" cy="0"/>
+        </a:xfrm>
+      </p:grpSpPr>
+      <p:pic>
+        <p:nvPicPr>
+          <p:cNvPr descr="img/dodecaedre-et-tore-avec-patron.png" id="0" name="Picture 1"/>
+          <p:cNvPicPr>
+            <a:picLocks noGrp="1" noChangeAspect="1"/>
+          </p:cNvPicPr>
+          <p:nvPr/>
+        </p:nvPicPr>
+        <p:blipFill>
+          <a:blip r:embed="rId2"/>
+          <a:stretch>
+            <a:fillRect/>
+          </a:stretch>
+        </p:blipFill>
+        <p:spPr bwMode="auto">
+          <a:xfrm>
+            <a:off x="787400" y="1600200"/>
+            <a:ext cx="7556500" cy="4521200"/>
+          </a:xfrm>
+          <a:prstGeom prst="rect">
+            <a:avLst/>
+          </a:prstGeom>
+          <a:noFill/>
+          <a:ln w="9525">
+            <a:noFill/>
+            <a:headEnd/>
+            <a:tailEnd/>
+          </a:ln>
+        </p:spPr>
+      </p:pic>
+    </p:spTree>
+  </p:cSld>
+</p:sld>
+</file>
+
+<file path=ppt/slides/slide8.xml><?xml version="1.0" encoding="utf-8"?>
+<p:sld xmlns:a="http://schemas.openxmlformats.org/drawingml/2006/main" xmlns:r="http://schemas.openxmlformats.org/officeDocument/2006/relationships" xmlns:p="http://schemas.openxmlformats.org/presentationml/2006/main">
+  <p:cSld>
+    <p:spTree>
+      <p:nvGrpSpPr>
+        <p:cNvPr id="1" name=""/>
+        <p:cNvGrpSpPr/>
+        <p:nvPr/>
+      </p:nvGrpSpPr>
+      <p:grpSpPr>
+        <a:xfrm>
+          <a:off x="0" y="0"/>
+          <a:ext cx="0" cy="0"/>
+          <a:chOff x="0" y="0"/>
+          <a:chExt cx="0" cy="0"/>
+        </a:xfrm>
+      </p:grpSpPr>
+      <p:sp>
+        <p:nvSpPr>
+          <p:cNvPr id="3" name="Content Placeholder 2"/>
+          <p:cNvSpPr>
+            <a:spLocks noGrp="1"/>
+          </p:cNvSpPr>
+          <p:nvPr>
+            <p:ph idx="1"/>
+          </p:nvPr>
+        </p:nvSpPr>
+        <p:spPr/>
+        <p:txBody>
+          <a:bodyPr/>
+          <a:lstStyle/>
+          <a:p>
+            <a:pPr lvl="0" marL="0" indent="0">
+              <a:buNone/>
+            </a:pPr>
+            <a:r>
+              <a:rPr/>
+              <a:t>Diverses techniques de représentation de polyèdres</a:t>
+            </a:r>
+          </a:p>
+        </p:txBody>
+      </p:sp>
+    </p:spTree>
+  </p:cSld>
+</p:sld>
+</file>
+
+<file path=ppt/slides/slide9.xml><?xml version="1.0" encoding="utf-8"?>
 <p:sld xmlns:a="http://schemas.openxmlformats.org/drawingml/2006/main" xmlns:r="http://schemas.openxmlformats.org/officeDocument/2006/relationships" xmlns:p="http://schemas.openxmlformats.org/presentationml/2006/main">
   <p:cSld>
     <p:spTree>
@@ -5680,7 +5842,7 @@
                 </a14:m>
                 <a:r>
                   <a:rPr/>
-                  <a:t>N: un assistant de preuves</a:t>
+                  <a:t>N: un assistant de preuves (prononcer «linne»)</a:t>
                 </a:r>
               </a:p>
               <a:p>
@@ -5689,16 +5851,7 @@
                 </a:pPr>
                 <a:r>
                   <a:rPr/>
-                  <a:t>Partenariat avec le département de mathématiques d’Orsay (P. Massot).</a:t>
-                </a:r>
-              </a:p>
-              <a:p>
-                <a:pPr lvl="0" marL="0" indent="0">
-                  <a:buNone/>
-                </a:pPr>
-                <a:r>
-                  <a:rPr/>
-                  <a:t>Données : </a:t>
+                  <a:t>Utilisé en L1 math-info </a:t>
                 </a:r>
                 <a:r>
                   <a:rPr>
@@ -5708,165 +5861,13 @@
                 </a:r>
                 <a:r>
                   <a:rPr/>
-                  <a:t> en L1 Math-Info à la faculté des Sciences d’Orsay.</a:t>
+                  <a:t> par Patrick Massot, prof d’université en mathématiques à Orsay</a:t>
                 </a:r>
-              </a:p>
-              <a:p>
-                <a:pPr lvl="0" marL="0" indent="0">
-                  <a:buNone/>
-                </a:pPr>
               </a:p>
             </p:txBody>
           </p:sp>
         </mc:Choice>
       </mc:AlternateContent>
-    </p:spTree>
-  </p:cSld>
-</p:sld>
-</file>
-
-<file path=ppt/slides/slide8.xml><?xml version="1.0" encoding="utf-8"?>
-<p:sld xmlns:a="http://schemas.openxmlformats.org/drawingml/2006/main" xmlns:r="http://schemas.openxmlformats.org/officeDocument/2006/relationships" xmlns:p="http://schemas.openxmlformats.org/presentationml/2006/main">
-  <p:cSld>
-    <p:spTree>
-      <p:nvGrpSpPr>
-        <p:cNvPr id="1" name=""/>
-        <p:cNvGrpSpPr/>
-        <p:nvPr/>
-      </p:nvGrpSpPr>
-      <p:grpSpPr>
-        <a:xfrm>
-          <a:off x="0" y="0"/>
-          <a:ext cx="0" cy="0"/>
-          <a:chOff x="0" y="0"/>
-          <a:chExt cx="0" cy="0"/>
-        </a:xfrm>
-      </p:grpSpPr>
-      <p:sp>
-        <p:nvSpPr>
-          <p:cNvPr id="3" name="Content Placeholder 2"/>
-          <p:cNvSpPr>
-            <a:spLocks noGrp="1"/>
-          </p:cNvSpPr>
-          <p:nvPr>
-            <p:ph idx="1"/>
-          </p:nvPr>
-        </p:nvSpPr>
-        <p:spPr/>
-        <p:txBody>
-          <a:bodyPr/>
-          <a:lstStyle/>
-          <a:p>
-            <a:pPr lvl="0" marL="0" indent="0">
-              <a:spcBef>
-                <a:spcPts val="3000"/>
-              </a:spcBef>
-              <a:buNone/>
-            </a:pPr>
-            <a:r>
-              <a:rPr b="1"/>
-              <a:t>Mes compétences et les thématiques de l’ADEF</a:t>
-            </a:r>
-          </a:p>
-          <a:p>
-            <a:pPr lvl="0" marL="0" indent="0">
-              <a:buNone/>
-            </a:pPr>
-            <a:r>
-              <a:rPr/>
-              <a:t>Je suis une «maker».</a:t>
-            </a:r>
-          </a:p>
-          <a:p>
-            <a:pPr lvl="0" marL="0" indent="0">
-              <a:buNone/>
-            </a:pPr>
-            <a:r>
-              <a:rPr/>
-              <a:t>Je crée et j’étudie des objets mathématiques.</a:t>
-            </a:r>
-          </a:p>
-          <a:p>
-            <a:pPr lvl="0" marL="0" indent="0">
-              <a:buNone/>
-            </a:pPr>
-            <a:r>
-              <a:rPr/>
-              <a:t>Ces objets peuvent devenir ensuite des instruments dans des situations d’enseignement -apprentissage.</a:t>
-            </a:r>
-          </a:p>
-          <a:p>
-            <a:pPr lvl="0" marL="0" indent="0">
-              <a:buNone/>
-            </a:pPr>
-            <a:r>
-              <a:rPr/>
-              <a:t>Ces instruments, par la suite, seront générateurs de projets de recherche en didactique.</a:t>
-            </a:r>
-          </a:p>
-          <a:p>
-            <a:pPr lvl="0" marL="0" indent="0">
-              <a:buNone/>
-            </a:pPr>
-            <a:r>
-              <a:rPr/>
-              <a:t>Par conséquent, l’équipe qui me correspond le mieux à l’ADEF est l’équipe EAST.</a:t>
-            </a:r>
-          </a:p>
-        </p:txBody>
-      </p:sp>
-    </p:spTree>
-  </p:cSld>
-</p:sld>
-</file>
-
-<file path=ppt/slides/slide9.xml><?xml version="1.0" encoding="utf-8"?>
-<p:sld xmlns:a="http://schemas.openxmlformats.org/drawingml/2006/main" xmlns:r="http://schemas.openxmlformats.org/officeDocument/2006/relationships" xmlns:p="http://schemas.openxmlformats.org/presentationml/2006/main">
-  <p:cSld>
-    <p:spTree>
-      <p:nvGrpSpPr>
-        <p:cNvPr id="1" name=""/>
-        <p:cNvGrpSpPr/>
-        <p:nvPr/>
-      </p:nvGrpSpPr>
-      <p:grpSpPr>
-        <a:xfrm>
-          <a:off x="0" y="0"/>
-          <a:ext cx="0" cy="0"/>
-          <a:chOff x="0" y="0"/>
-          <a:chExt cx="0" cy="0"/>
-        </a:xfrm>
-      </p:grpSpPr>
-      <p:pic>
-        <p:nvPicPr>
-          <p:cNvPr descr="img/dini-alba.png" id="0" name="Picture 1"/>
-          <p:cNvPicPr>
-            <a:picLocks noGrp="1" noChangeAspect="1"/>
-          </p:cNvPicPr>
-          <p:nvPr/>
-        </p:nvPicPr>
-        <p:blipFill>
-          <a:blip r:embed="rId2"/>
-          <a:stretch>
-            <a:fillRect/>
-          </a:stretch>
-        </p:blipFill>
-        <p:spPr bwMode="auto">
-          <a:xfrm>
-            <a:off x="939800" y="1600200"/>
-            <a:ext cx="7251700" cy="4521200"/>
-          </a:xfrm>
-          <a:prstGeom prst="rect">
-            <a:avLst/>
-          </a:prstGeom>
-          <a:noFill/>
-          <a:ln w="9525">
-            <a:noFill/>
-            <a:headEnd/>
-            <a:tailEnd/>
-          </a:ln>
-        </p:spPr>
-      </p:pic>
     </p:spTree>
   </p:cSld>
 </p:sld>

</xml_diff>

<commit_message>
more improvements on teaching slides
</commit_message>
<xml_diff>
--- a/2020-06-01.pptx
+++ b/2020-06-01.pptx
@@ -3478,6 +3478,46 @@
               <a:t>projet «Plagiarism prevention»</a:t>
             </a:r>
           </a:p>
+          <a:p>
+            <a:pPr lvl="0" marL="0" indent="0">
+              <a:buNone/>
+            </a:pPr>
+          </a:p>
+          <a:p>
+            <a:pPr lvl="1"/>
+            <a:r>
+              <a:rPr/>
+              <a:t>interactions avec des enseignants:</a:t>
+            </a:r>
+          </a:p>
+          <a:p>
+            <a:pPr lvl="2"/>
+            <a:r>
+              <a:rPr/>
+              <a:t>salons et festivals</a:t>
+            </a:r>
+          </a:p>
+          <a:p>
+            <a:pPr lvl="2"/>
+            <a:r>
+              <a:rPr/>
+              <a:t>fêtes de la science</a:t>
+            </a:r>
+          </a:p>
+          <a:p>
+            <a:pPr lvl="2"/>
+            <a:r>
+              <a:rPr/>
+              <a:t>visites en classes</a:t>
+            </a:r>
+          </a:p>
+          <a:p>
+            <a:pPr lvl="2"/>
+            <a:r>
+              <a:rPr/>
+              <a:t>et aussi dans les MOOC</a:t>
+            </a:r>
+          </a:p>
         </p:txBody>
       </p:sp>
     </p:spTree>
@@ -3502,36 +3542,119 @@
           <a:chExt cx="0" cy="0"/>
         </a:xfrm>
       </p:grpSpPr>
-      <p:pic>
-        <p:nvPicPr>
-          <p:cNvPr descr="img/reussite-fun-edx.png" id="0" name="Picture 1"/>
-          <p:cNvPicPr>
-            <a:picLocks noGrp="1" noChangeAspect="1"/>
-          </p:cNvPicPr>
-          <p:nvPr/>
-        </p:nvPicPr>
-        <p:blipFill>
-          <a:blip r:embed="rId2"/>
-          <a:stretch>
-            <a:fillRect/>
-          </a:stretch>
-        </p:blipFill>
-        <p:spPr bwMode="auto">
-          <a:xfrm>
-            <a:off x="457200" y="2565400"/>
-            <a:ext cx="8229600" cy="2603500"/>
-          </a:xfrm>
-          <a:prstGeom prst="rect">
-            <a:avLst/>
-          </a:prstGeom>
-          <a:noFill/>
-          <a:ln w="9525">
-            <a:noFill/>
-            <a:headEnd/>
-            <a:tailEnd/>
-          </a:ln>
-        </p:spPr>
-      </p:pic>
+      <p:sp>
+        <p:nvSpPr>
+          <p:cNvPr id="3" name="Content Placeholder 2"/>
+          <p:cNvSpPr>
+            <a:spLocks noGrp="1"/>
+          </p:cNvSpPr>
+          <p:nvPr>
+            <p:ph idx="1"/>
+          </p:nvPr>
+        </p:nvSpPr>
+        <p:spPr/>
+        <p:txBody>
+          <a:bodyPr/>
+          <a:lstStyle/>
+          <a:p>
+            <a:pPr lvl="0" marL="0" indent="0">
+              <a:spcBef>
+                <a:spcPts val="3000"/>
+              </a:spcBef>
+              <a:buNone/>
+            </a:pPr>
+            <a:r>
+              <a:rPr b="1"/>
+              <a:t>Formation des professeurs des écoles</a:t>
+            </a:r>
+          </a:p>
+          <a:p>
+            <a:pPr lvl="0" marL="0" indent="0">
+              <a:buNone/>
+            </a:pPr>
+            <a:r>
+              <a:rPr/>
+              <a:t>Trois étapes:</a:t>
+            </a:r>
+          </a:p>
+          <a:p>
+            <a:pPr lvl="1"/>
+            <a:r>
+              <a:rPr>
+                <a:hlinkClick r:id="rId2"/>
+              </a:rPr>
+              <a:t>cycle 1</a:t>
+            </a:r>
+            <a:r>
+              <a:rPr/>
+              <a:t> – apprentissages premiers</a:t>
+            </a:r>
+          </a:p>
+          <a:p>
+            <a:pPr lvl="1"/>
+            <a:r>
+              <a:rPr>
+                <a:hlinkClick r:id="rId3"/>
+              </a:rPr>
+              <a:t>cycle 2</a:t>
+            </a:r>
+            <a:r>
+              <a:rPr/>
+              <a:t> – apprentissages fondamentaux</a:t>
+            </a:r>
+          </a:p>
+          <a:p>
+            <a:pPr lvl="1"/>
+            <a:r>
+              <a:rPr>
+                <a:hlinkClick r:id="rId4"/>
+              </a:rPr>
+              <a:t>cycle 3</a:t>
+            </a:r>
+            <a:r>
+              <a:rPr/>
+              <a:t> – consolidation, lien avec le collège</a:t>
+            </a:r>
+          </a:p>
+          <a:p>
+            <a:pPr lvl="0" marL="0" indent="0">
+              <a:buNone/>
+            </a:pPr>
+            <a:r>
+              <a:rPr/>
+              <a:t>Formation professionnalisante donc équilibre entre:</a:t>
+            </a:r>
+          </a:p>
+          <a:p>
+            <a:pPr lvl="1"/>
+            <a:r>
+              <a:rPr/>
+              <a:t>besoins du métier</a:t>
+            </a:r>
+          </a:p>
+          <a:p>
+            <a:pPr lvl="1"/>
+            <a:r>
+              <a:rPr/>
+              <a:t>approche scientifique Formation interdisciplinaire donc équilibre entre:</a:t>
+            </a:r>
+          </a:p>
+          <a:p>
+            <a:pPr lvl="1"/>
+            <a:r>
+              <a:rPr/>
+              <a:t>s’assurer d’une maîtrise des mathématiques fondamentales</a:t>
+            </a:r>
+          </a:p>
+          <a:p>
+            <a:pPr lvl="1"/>
+            <a:r>
+              <a:rPr/>
+              <a:t>former à un enseignement des mathématiques ancrée dans le monde</a:t>
+            </a:r>
+          </a:p>
+        </p:txBody>
+      </p:sp>
     </p:spTree>
   </p:cSld>
 </p:sld>
@@ -3569,38 +3692,101 @@
           <a:bodyPr/>
           <a:lstStyle/>
           <a:p>
+            <a:pPr lvl="0" marL="0" indent="0">
+              <a:spcBef>
+                <a:spcPts val="3000"/>
+              </a:spcBef>
+              <a:buNone/>
+            </a:pPr>
+            <a:r>
+              <a:rPr b="1"/>
+              <a:t>Formation des professeurs certifiés</a:t>
+            </a:r>
+          </a:p>
+          <a:p>
+            <a:pPr lvl="0" marL="0" indent="0">
+              <a:buNone/>
+            </a:pPr>
+            <a:r>
+              <a:rPr/>
+              <a:t>Collège: - </a:t>
+            </a:r>
+            <a:r>
+              <a:rPr>
+                <a:hlinkClick r:id="rId2"/>
+              </a:rPr>
+              <a:t>cycle 3</a:t>
+            </a:r>
+            <a:r>
+              <a:rPr/>
+              <a:t> – consolidation, lien avec le primaire - </a:t>
+            </a:r>
+            <a:r>
+              <a:rPr>
+                <a:hlinkClick r:id="rId3"/>
+              </a:rPr>
+              <a:t>cycle 4</a:t>
+            </a:r>
+            <a:r>
+              <a:rPr/>
+              <a:t> – approfondissements</a:t>
+            </a:r>
+          </a:p>
+          <a:p>
+            <a:pPr lvl="0" marL="0" indent="0">
+              <a:buNone/>
+            </a:pPr>
+            <a:r>
+              <a:rPr>
+                <a:hlinkClick r:id="rId4"/>
+              </a:rPr>
+              <a:t>Lycée général et technologique</a:t>
+            </a:r>
+          </a:p>
+          <a:p>
+            <a:pPr lvl="0" marL="0" indent="0">
+              <a:buNone/>
+            </a:pPr>
+            <a:r>
+              <a:rPr/>
+              <a:t>Formation professionnalisante donc équilibre entre:</a:t>
+            </a:r>
+          </a:p>
+          <a:p>
             <a:pPr lvl="1"/>
             <a:r>
               <a:rPr/>
-              <a:t>interactions avec des enseignants:</a:t>
-            </a:r>
-          </a:p>
-          <a:p>
-            <a:pPr lvl="2"/>
-            <a:r>
-              <a:rPr/>
-              <a:t>salons et festivals</a:t>
-            </a:r>
-          </a:p>
-          <a:p>
-            <a:pPr lvl="2"/>
-            <a:r>
-              <a:rPr/>
-              <a:t>fêtes de la science</a:t>
-            </a:r>
-          </a:p>
-          <a:p>
-            <a:pPr lvl="2"/>
-            <a:r>
-              <a:rPr/>
-              <a:t>visites en classes</a:t>
-            </a:r>
-          </a:p>
-          <a:p>
-            <a:pPr lvl="2"/>
-            <a:r>
-              <a:rPr/>
-              <a:t>et aussi dans les MOOC</a:t>
+              <a:t>besoins du métier</a:t>
+            </a:r>
+          </a:p>
+          <a:p>
+            <a:pPr lvl="1"/>
+            <a:r>
+              <a:rPr/>
+              <a:t>approche scientifique</a:t>
+            </a:r>
+          </a:p>
+          <a:p>
+            <a:pPr lvl="0" marL="0" indent="0">
+              <a:buNone/>
+            </a:pPr>
+            <a:r>
+              <a:rPr/>
+              <a:t>Formation interdisciplinaire donc équilibre entre:</a:t>
+            </a:r>
+          </a:p>
+          <a:p>
+            <a:pPr lvl="1"/>
+            <a:r>
+              <a:rPr/>
+              <a:t>s’assurer d’une maîtrise des mathématiques fondamentales</a:t>
+            </a:r>
+          </a:p>
+          <a:p>
+            <a:pPr lvl="1"/>
+            <a:r>
+              <a:rPr/>
+              <a:t>former à un enseignement des mathématiques qui aident à comprendre le monde</a:t>
             </a:r>
           </a:p>
         </p:txBody>
@@ -3627,311 +3813,41 @@
           <a:chExt cx="0" cy="0"/>
         </a:xfrm>
       </p:grpSpPr>
-      <mc:AlternateContent xmlns:mc="http://schemas.openxmlformats.org/markup-compatibility/2006">
-        <mc:Choice xmlns:a14="http://schemas.microsoft.com/office/drawing/2010/main" Requires="a14">
-          <p:sp>
-            <p:nvSpPr>
-              <p:cNvPr id="3" name="Content Placeholder 2"/>
-              <p:cNvSpPr>
-                <a:spLocks noGrp="1"/>
-              </p:cNvSpPr>
-              <p:nvPr>
-                <p:ph idx="1"/>
-              </p:nvPr>
-            </p:nvSpPr>
-            <p:spPr/>
-            <p:txBody>
-              <a:bodyPr/>
-              <a:lstStyle/>
-              <a:p>
-                <a:pPr lvl="0" marL="0" indent="0">
-                  <a:spcBef>
-                    <a:spcPts val="3000"/>
-                  </a:spcBef>
-                  <a:buNone/>
-                </a:pPr>
-                <a:r>
-                  <a:rPr b="1"/>
-                  <a:t>Formation des professeurs des écoles</a:t>
-                </a:r>
-              </a:p>
-              <a:p>
-                <a:pPr lvl="0" marL="0" indent="0">
-                  <a:buNone/>
-                </a:pPr>
-                <a:r>
-                  <a:rPr/>
-                  <a:t>Trois étapes (programmes sur Eduscol):</a:t>
-                </a:r>
-              </a:p>
-              <a:p>
-                <a:pPr lvl="1"/>
-                <a:r>
-                  <a:rPr>
-                    <a:hlinkClick r:id="rId2"/>
-                  </a:rPr>
-                  <a:t>cycle 1</a:t>
-                </a:r>
-                <a:r>
-                  <a:rPr/>
-                  <a:t> – apprentissages premiers</a:t>
-                </a:r>
-              </a:p>
-              <a:p>
-                <a:pPr lvl="1"/>
-                <a:r>
-                  <a:rPr>
-                    <a:hlinkClick r:id="rId3"/>
-                  </a:rPr>
-                  <a:t>cycle 2</a:t>
-                </a:r>
-                <a:r>
-                  <a:rPr/>
-                  <a:t> – apprentissages fondamentaux</a:t>
-                </a:r>
-              </a:p>
-              <a:p>
-                <a:pPr lvl="1"/>
-                <a:r>
-                  <a:rPr>
-                    <a:hlinkClick r:id="rId4"/>
-                  </a:rPr>
-                  <a:t>cycle 3</a:t>
-                </a:r>
-                <a:r>
-                  <a:rPr/>
-                  <a:t> (</a:t>
-                </a:r>
-                <a14:m>
-                  <m:oMath xmlns:m="http://schemas.openxmlformats.org/officeDocument/2006/math">
-                    <m:r>
-                      <m:t>⅔</m:t>
-                    </m:r>
-                  </m:oMath>
-                </a14:m>
-                <a:r>
-                  <a:rPr/>
-                  <a:t>) – consolidation</a:t>
-                </a:r>
-              </a:p>
-              <a:p>
-                <a:pPr lvl="0" marL="0" indent="0">
-                  <a:buNone/>
-                </a:pPr>
-                <a:r>
-                  <a:rPr/>
-                  <a:t>Formation professionnalisante donc équilibre entre:</a:t>
-                </a:r>
-              </a:p>
-              <a:p>
-                <a:pPr lvl="1"/>
-                <a:r>
-                  <a:rPr/>
-                  <a:t>besoins du métier</a:t>
-                </a:r>
-              </a:p>
-              <a:p>
-                <a:pPr lvl="1"/>
-                <a:r>
-                  <a:rPr/>
-                  <a:t>approche scientifique</a:t>
-                </a:r>
-              </a:p>
-              <a:p>
-                <a:pPr lvl="1"/>
-                <a:r>
-                  <a:rPr/>
-                  <a:t>préparation aux concours</a:t>
-                </a:r>
-              </a:p>
-              <a:p>
-                <a:pPr lvl="0" marL="0" indent="0">
-                  <a:buNone/>
-                </a:pPr>
-                <a:r>
-                  <a:rPr/>
-                  <a:t>Formation interdisciplinaire donc équilibre entre:</a:t>
-                </a:r>
-              </a:p>
-              <a:p>
-                <a:pPr lvl="1"/>
-                <a:r>
-                  <a:rPr/>
-                  <a:t>s’assurer d’une maîtrise des mathématiques fondamentales</a:t>
-                </a:r>
-              </a:p>
-              <a:p>
-                <a:pPr lvl="1"/>
-                <a:r>
-                  <a:rPr/>
-                  <a:t>former à un enseignement des mathématiques placées dans le monde</a:t>
-                </a:r>
-              </a:p>
-            </p:txBody>
-          </p:sp>
-        </mc:Choice>
-      </mc:AlternateContent>
+      <p:sp>
+        <p:nvSpPr>
+          <p:cNvPr id="3" name="Content Placeholder 2"/>
+          <p:cNvSpPr>
+            <a:spLocks noGrp="1"/>
+          </p:cNvSpPr>
+          <p:nvPr>
+            <p:ph idx="1"/>
+          </p:nvPr>
+        </p:nvSpPr>
+        <p:spPr/>
+        <p:txBody>
+          <a:bodyPr/>
+          <a:lstStyle/>
+          <a:p>
+            <a:pPr lvl="0" marL="0" indent="0">
+              <a:spcBef>
+                <a:spcPts val="3000"/>
+              </a:spcBef>
+              <a:buNone/>
+            </a:pPr>
+            <a:r>
+              <a:rPr b="1"/>
+              <a:t>Proposition de collaboration entre étudiants</a:t>
+            </a:r>
+          </a:p>
+        </p:txBody>
+      </p:sp>
     </p:spTree>
   </p:cSld>
 </p:sld>
 </file>
 
-<file path=ppt/slides/slide15.xml><?xml version="1.0" encoding="utf-8"?>
-<p:sld xmlns:a="http://schemas.openxmlformats.org/drawingml/2006/main" xmlns:r="http://schemas.openxmlformats.org/officeDocument/2006/relationships" xmlns:p="http://schemas.openxmlformats.org/presentationml/2006/main">
-  <p:cSld>
-    <p:spTree>
-      <p:nvGrpSpPr>
-        <p:cNvPr id="1" name=""/>
-        <p:cNvGrpSpPr/>
-        <p:nvPr/>
-      </p:nvGrpSpPr>
-      <p:grpSpPr>
-        <a:xfrm>
-          <a:off x="0" y="0"/>
-          <a:ext cx="0" cy="0"/>
-          <a:chOff x="0" y="0"/>
-          <a:chExt cx="0" cy="0"/>
-        </a:xfrm>
-      </p:grpSpPr>
-      <mc:AlternateContent xmlns:mc="http://schemas.openxmlformats.org/markup-compatibility/2006">
-        <mc:Choice xmlns:a14="http://schemas.microsoft.com/office/drawing/2010/main" Requires="a14">
-          <p:sp>
-            <p:nvSpPr>
-              <p:cNvPr id="3" name="Content Placeholder 2"/>
-              <p:cNvSpPr>
-                <a:spLocks noGrp="1"/>
-              </p:cNvSpPr>
-              <p:nvPr>
-                <p:ph idx="1"/>
-              </p:nvPr>
-            </p:nvSpPr>
-            <p:spPr/>
-            <p:txBody>
-              <a:bodyPr/>
-              <a:lstStyle/>
-              <a:p>
-                <a:pPr lvl="0" marL="0" indent="0">
-                  <a:spcBef>
-                    <a:spcPts val="3000"/>
-                  </a:spcBef>
-                  <a:buNone/>
-                </a:pPr>
-                <a:r>
-                  <a:rPr b="1"/>
-                  <a:t>Formation des professeurs certifiés</a:t>
-                </a:r>
-              </a:p>
-              <a:p>
-                <a:pPr lvl="0" marL="0" indent="0">
-                  <a:buNone/>
-                </a:pPr>
-                <a:r>
-                  <a:rPr/>
-                  <a:t>Collège: - </a:t>
-                </a:r>
-                <a:r>
-                  <a:rPr>
-                    <a:hlinkClick r:id="rId2"/>
-                  </a:rPr>
-                  <a:t>cycle 3</a:t>
-                </a:r>
-                <a:r>
-                  <a:rPr/>
-                  <a:t> (</a:t>
-                </a:r>
-                <a14:m>
-                  <m:oMath xmlns:m="http://schemas.openxmlformats.org/officeDocument/2006/math">
-                    <m:r>
-                      <m:t>⅓</m:t>
-                    </m:r>
-                  </m:oMath>
-                </a14:m>
-                <a:r>
-                  <a:rPr/>
-                  <a:t>) – consolidation - </a:t>
-                </a:r>
-                <a:r>
-                  <a:rPr>
-                    <a:hlinkClick r:id="rId3"/>
-                  </a:rPr>
-                  <a:t>cycle 4</a:t>
-                </a:r>
-                <a:r>
-                  <a:rPr/>
-                  <a:t> – approfondissements</a:t>
-                </a:r>
-              </a:p>
-              <a:p>
-                <a:pPr lvl="0" marL="0" indent="0">
-                  <a:buNone/>
-                </a:pPr>
-                <a:r>
-                  <a:rPr>
-                    <a:hlinkClick r:id="rId4"/>
-                  </a:rPr>
-                  <a:t>Lycée général et technologique</a:t>
-                </a:r>
-              </a:p>
-              <a:p>
-                <a:pPr lvl="0" marL="0" indent="0">
-                  <a:buNone/>
-                </a:pPr>
-                <a:r>
-                  <a:rPr/>
-                  <a:t>Formation professionnalisante donc équilibre entre:</a:t>
-                </a:r>
-              </a:p>
-              <a:p>
-                <a:pPr lvl="1"/>
-                <a:r>
-                  <a:rPr/>
-                  <a:t>besoins du métier</a:t>
-                </a:r>
-              </a:p>
-              <a:p>
-                <a:pPr lvl="1"/>
-                <a:r>
-                  <a:rPr/>
-                  <a:t>approche scientifique</a:t>
-                </a:r>
-              </a:p>
-              <a:p>
-                <a:pPr lvl="1"/>
-                <a:r>
-                  <a:rPr/>
-                  <a:t>préparation aux concours</a:t>
-                </a:r>
-              </a:p>
-              <a:p>
-                <a:pPr lvl="0" marL="0" indent="0">
-                  <a:buNone/>
-                </a:pPr>
-                <a:r>
-                  <a:rPr/>
-                  <a:t>Formation interdisciplinaire donc équilibre entre:</a:t>
-                </a:r>
-              </a:p>
-              <a:p>
-                <a:pPr lvl="1"/>
-                <a:r>
-                  <a:rPr/>
-                  <a:t>s’assurer d’une maîtrise des mathématiques fondamentales</a:t>
-                </a:r>
-              </a:p>
-              <a:p>
-                <a:pPr lvl="1"/>
-                <a:r>
-                  <a:rPr/>
-                  <a:t>former à un enseignement des mathématiques qui aident à comprendre le monde</a:t>
-                </a:r>
-              </a:p>
-            </p:txBody>
-          </p:sp>
-        </mc:Choice>
-      </mc:AlternateContent>
-    </p:spTree>
-  </p:cSld>
-</p:sld>
+<file path=ppt/slides/slide15.xml><?xml version="1.0" encoding="UTF-8"?>
+<p:sld xmlns:a="http://schemas.openxmlformats.org/drawingml/2006/main" xmlns:r="http://schemas.openxmlformats.org/officeDocument/2006/relationships" xmlns:p="http://schemas.openxmlformats.org/presentationml/2006/main"><p:cSld><p:spTree><p:nvGrpSpPr><p:cNvPr id="1" name="" /><p:cNvGrpSpPr /><p:nvPr /></p:nvGrpSpPr><p:grpSpPr><a:xfrm><a:off x="0" y="0" /><a:ext cx="0" cy="0" /><a:chOff x="0" y="0" /><a:chExt cx="0" cy="0" /></a:xfrm></p:grpSpPr><p:graphicFrame><p:nvGraphicFramePr><p:cNvPr id="6" name="Content Placeholder 5" /><p:cNvGraphicFramePr><a:graphicFrameLocks noGrp="1" /></p:cNvGraphicFramePr><p:nvPr><p:ph idx="1" /></p:nvPr></p:nvGraphicFramePr><p:xfrm><a:off x="457200" y="1600200" /><a:ext cx="8229600" cy="4521200" /></p:xfrm><a:graphic><a:graphicData uri="http://schemas.openxmlformats.org/drawingml/2006/table"><a:tbl><a:tblPr firstRow="1" bandRow="1"><a:tableStyleId>{5C22544A-7EE6-4342-B048-85BDC9FD1C3A}</a:tableStyleId></a:tblPr><a:tblGrid><a:gridCol w="2743200" /><a:gridCol w="2743200" /><a:gridCol w="2743200" /></a:tblGrid><a:tr h="0"><a:tc><a:txBody><a:bodyPr /><a:lstStyle /><a:p><a:pPr lvl="0" marL="0" indent="0" algn="l"><a:buNone /></a:pPr><a:r><a:rPr /><a:t>USA</a:t></a:r></a:p></a:txBody></a:tc><a:tc><a:txBody><a:bodyPr /><a:lstStyle /><a:p><a:pPr lvl="0" marL="0" indent="0" algn="ctr"><a:buNone /></a:pPr><a14:m><m:oMath xmlns:m="http://schemas.openxmlformats.org/officeDocument/2006/math"><m:r><m:t>↔</m:t></m:r></m:oMath></a14:m></a:p></a:txBody></a:tc><a:tc><a:txBody><a:bodyPr /><a:lstStyle /><a:p><a:pPr lvl="0" marL="0" indent="0" algn="r"><a:buNone /></a:pPr><a:r><a:rPr /><a:t>France</a:t></a:r></a:p></a:txBody></a:tc></a:tr><a:tr h="0"><a:tc><a:txBody><a:bodyPr /><a:lstStyle /><a:p><a:pPr lvl="0" marL="0" indent="0" algn="l"><a:buNone /></a:pPr><a:r><a:rPr /><a:t>U.</a:t></a:r><a:r><a:rPr /><a:t> </a:t></a:r><a:r><a:rPr /><a:t>Washington</a:t></a:r></a:p></a:txBody></a:tc><a:tc><a:txBody><a:bodyPr /><a:lstStyle /><a:p><a:endParaRPr /></a:p></a:txBody></a:tc><a:tc><a:txBody><a:bodyPr /><a:lstStyle /><a:p><a:pPr lvl="0" marL="0" indent="0" algn="r"><a:buNone /></a:pPr><a:r><a:rPr /><a:t>Inspé</a:t></a:r><a:r><a:rPr /><a:t> </a:t></a:r><a:r><a:rPr /><a:t>Marseille</a:t></a:r></a:p></a:txBody></a:tc></a:tr><a:tr h="0"><a:tc><a:txBody><a:bodyPr /><a:lstStyle /><a:p><a:pPr lvl="0" marL="0" indent="0" algn="l"><a:buNone /></a:pPr><a:r><a:rPr /><a:t>3-4</a:t></a:r><a:r><a:rPr /><a:t> </a:t></a:r><a:r><a:rPr /><a:t>students</a:t></a:r></a:p></a:txBody></a:tc><a:tc><a:txBody><a:bodyPr /><a:lstStyle /><a:p><a:endParaRPr /></a:p></a:txBody></a:tc><a:tc><a:txBody><a:bodyPr /><a:lstStyle /><a:p><a:pPr lvl="0" marL="0" indent="0" algn="r"><a:buNone /></a:pPr><a:r><a:rPr /><a:t>3-4</a:t></a:r><a:r><a:rPr /><a:t> </a:t></a:r><a:r><a:rPr /><a:t>étudiants</a:t></a:r></a:p></a:txBody></a:tc></a:tr><a:tr h="0"><a:tc><a:txBody><a:bodyPr /><a:lstStyle /><a:p><a:pPr lvl="0" marL="0" indent="0" algn="l"><a:buNone /></a:pPr><a:r><a:rPr /><a:t>J.</a:t></a:r><a:r><a:rPr /><a:t> </a:t></a:r><a:r><a:rPr /><a:t>Athreya</a:t></a:r></a:p></a:txBody></a:tc><a:tc><a:txBody><a:bodyPr /><a:lstStyle /><a:p><a:endParaRPr /></a:p></a:txBody></a:tc><a:tc><a:txBody><a:bodyPr /><a:lstStyle /><a:p><a:pPr lvl="0" marL="0" indent="0" algn="r"><a:buNone /></a:pPr><a:r><a:rPr /><a:t>A.</a:t></a:r><a:r><a:rPr /><a:t> </a:t></a:r><a:r><a:rPr /><a:t>Málaga</a:t></a:r></a:p></a:txBody></a:tc></a:tr></a:tbl></a:graphicData></a:graphic></p:graphicFrame></p:spTree></p:cSld></p:sld>
 </file>
 
 <file path=ppt/slides/slide16.xml><?xml version="1.0" encoding="utf-8"?>
@@ -4118,6 +4034,118 @@
                       </a:pPr>
                       <a:r>
                         <a:rPr/>
+                        <a:t>Géométrie</a:t>
+                      </a:r>
+                      <a:r>
+                        <a:rPr/>
+                        <a:t> </a:t>
+                      </a:r>
+                      <a:r>
+                        <a:rPr/>
+                        <a:t>et</a:t>
+                      </a:r>
+                      <a:r>
+                        <a:rPr/>
+                        <a:t> </a:t>
+                      </a:r>
+                      <a:r>
+                        <a:rPr/>
+                        <a:t>systèmes</a:t>
+                      </a:r>
+                      <a:r>
+                        <a:rPr/>
+                        <a:t> </a:t>
+                      </a:r>
+                      <a:r>
+                        <a:rPr/>
+                        <a:t>dynamiques</a:t>
+                      </a:r>
+                    </a:p>
+                  </a:txBody>
+                </a:tc>
+                <a:tc>
+                  <a:txBody>
+                    <a:bodyPr/>
+                    <a:lstStyle/>
+                    <a:p>
+                      <a:pPr lvl="0" marL="0" indent="0">
+                        <a:buNone/>
+                      </a:pPr>
+                      <a:r>
+                        <a:rPr/>
+                        <a:t>Création</a:t>
+                      </a:r>
+                      <a:r>
+                        <a:rPr/>
+                        <a:t> </a:t>
+                      </a:r>
+                      <a:r>
+                        <a:rPr/>
+                        <a:t>de</a:t>
+                      </a:r>
+                      <a:r>
+                        <a:rPr/>
+                        <a:t> </a:t>
+                      </a:r>
+                      <a:r>
+                        <a:rPr/>
+                        <a:t>parcours</a:t>
+                      </a:r>
+                      <a:r>
+                        <a:rPr/>
+                        <a:t> </a:t>
+                      </a:r>
+                      <a:r>
+                        <a:rPr/>
+                        <a:t>de</a:t>
+                      </a:r>
+                      <a:r>
+                        <a:rPr/>
+                        <a:t> </a:t>
+                      </a:r>
+                      <a:r>
+                        <a:rPr/>
+                        <a:t>recherche</a:t>
+                      </a:r>
+                      <a:r>
+                        <a:rPr/>
+                        <a:t> </a:t>
+                      </a:r>
+                      <a:r>
+                        <a:rPr/>
+                        <a:t>pour</a:t>
+                      </a:r>
+                      <a:r>
+                        <a:rPr/>
+                        <a:t> </a:t>
+                      </a:r>
+                      <a:r>
+                        <a:rPr/>
+                        <a:t>les</a:t>
+                      </a:r>
+                      <a:r>
+                        <a:rPr/>
+                        <a:t> </a:t>
+                      </a:r>
+                      <a:r>
+                        <a:rPr/>
+                        <a:t>élèves</a:t>
+                      </a:r>
+                    </a:p>
+                  </a:txBody>
+                </a:tc>
+              </a:tr>
+              <a:tr h="0">
+                <a:tc>
+                  <a:txBody>
+                    <a:bodyPr/>
+                    <a:lstStyle/>
+                    <a:p>
+                      <a:pPr lvl="0" marL="0" indent="0">
+                        <a:buNone/>
+                      </a:pPr>
+                      <a:r>
+                        <a:rPr/>
                         <a:t>Impression</a:t>
                       </a:r>
                       <a:r>
@@ -4319,55 +4347,31 @@
                       </a:pPr>
                       <a:r>
                         <a:rPr/>
-                        <a:t>Prise</a:t>
-                      </a:r>
-                      <a:r>
-                        <a:rPr/>
-                        <a:t> </a:t>
-                      </a:r>
-                      <a:r>
-                        <a:rPr/>
-                        <a:t>en</a:t>
-                      </a:r>
-                      <a:r>
-                        <a:rPr/>
-                        <a:t> </a:t>
-                      </a:r>
-                      <a:r>
-                        <a:rPr/>
-                        <a:t>compte</a:t>
-                      </a:r>
-                      <a:r>
-                        <a:rPr/>
-                        <a:t> </a:t>
-                      </a:r>
-                      <a:r>
-                        <a:rPr/>
-                        <a:t>de</a:t>
-                      </a:r>
-                      <a:r>
-                        <a:rPr/>
-                        <a:t> </a:t>
-                      </a:r>
-                      <a:r>
-                        <a:rPr/>
-                        <a:t>la</a:t>
-                      </a:r>
-                      <a:r>
-                        <a:rPr/>
-                        <a:t> </a:t>
-                      </a:r>
-                      <a:r>
-                        <a:rPr/>
-                        <a:t>fracture</a:t>
-                      </a:r>
-                      <a:r>
-                        <a:rPr/>
-                        <a:t> </a:t>
-                      </a:r>
-                      <a:r>
-                        <a:rPr/>
-                        <a:t>numérique</a:t>
+                        <a:t>Usage</a:t>
+                      </a:r>
+                      <a:r>
+                        <a:rPr/>
+                        <a:t> </a:t>
+                      </a:r>
+                      <a:r>
+                        <a:rPr/>
+                        <a:t>d’une</a:t>
+                      </a:r>
+                      <a:r>
+                        <a:rPr/>
+                        <a:t> </a:t>
+                      </a:r>
+                      <a:r>
+                        <a:rPr/>
+                        <a:t>imprimante</a:t>
+                      </a:r>
+                      <a:r>
+                        <a:rPr/>
+                        <a:t> </a:t>
+                      </a:r>
+                      <a:r>
+                        <a:rPr/>
+                        <a:t>Braille</a:t>
                       </a:r>
                     </a:p>
                   </a:txBody>
@@ -4440,6 +4444,48 @@
                       <a:r>
                         <a:rPr/>
                         <a:t>mathématiques</a:t>
+                      </a:r>
+                    </a:p>
+                  </a:txBody>
+                </a:tc>
+              </a:tr>
+              <a:tr h="0">
+                <a:tc>
+                  <a:txBody>
+                    <a:bodyPr/>
+                    <a:lstStyle/>
+                    <a:p>
+                      <a:endParaRPr/>
+                    </a:p>
+                  </a:txBody>
+                </a:tc>
+                <a:tc>
+                  <a:txBody>
+                    <a:bodyPr/>
+                    <a:lstStyle/>
+                    <a:p>
+                      <a:pPr lvl="0" marL="0" indent="0">
+                        <a:buNone/>
+                      </a:pPr>
+                      <a:r>
+                        <a:rPr/>
+                        <a:t>Intégration</a:t>
+                      </a:r>
+                      <a:r>
+                        <a:rPr/>
+                        <a:t> </a:t>
+                      </a:r>
+                      <a:r>
+                        <a:rPr/>
+                        <a:t>des</a:t>
+                      </a:r>
+                      <a:r>
+                        <a:rPr/>
+                        <a:t> </a:t>
+                      </a:r>
+                      <a:r>
+                        <a:rPr/>
+                        <a:t>TICE</a:t>
                       </a:r>
                     </a:p>
                   </a:txBody>
@@ -4651,7 +4697,7 @@
 </file>
 
 <file path=ppt/slides/slide19.xml><?xml version="1.0" encoding="UTF-8"?>
-<p:sld xmlns:a="http://schemas.openxmlformats.org/drawingml/2006/main" xmlns:r="http://schemas.openxmlformats.org/officeDocument/2006/relationships" xmlns:p="http://schemas.openxmlformats.org/presentationml/2006/main"><p:cSld><p:spTree><p:nvGrpSpPr><p:cNvPr id="1" name="" /><p:cNvGrpSpPr /><p:nvPr /></p:nvGrpSpPr><p:grpSpPr><a:xfrm><a:off x="0" y="0" /><a:ext cx="0" cy="0" /><a:chOff x="0" y="0" /><a:chExt cx="0" cy="0" /></a:xfrm></p:grpSpPr><p:graphicFrame><p:nvGraphicFramePr><p:cNvPr id="6" name="Content Placeholder 5" /><p:cNvGraphicFramePr><a:graphicFrameLocks noGrp="1" /></p:cNvGraphicFramePr><p:nvPr><p:ph idx="1" /></p:nvPr></p:nvGraphicFramePr><p:xfrm><a:off x="457200" y="1600200" /><a:ext cx="8229600" cy="4521200" /></p:xfrm><a:graphic><a:graphicData uri="http://schemas.openxmlformats.org/drawingml/2006/table"><a:tbl><a:tblPr firstRow="1" bandRow="1"><a:tableStyleId>{5C22544A-7EE6-4342-B048-85BDC9FD1C3A}</a:tableStyleId></a:tblPr><a:tblGrid><a:gridCol w="4114800" /><a:gridCol w="4114800" /></a:tblGrid><a:tr h="0"><a:tc><a:txBody><a:bodyPr /><a:lstStyle /><a:p><a:pPr lvl="0" marL="0" indent="0" algn="l"><a:buNone /></a:pPr><a:r><a:rPr /><a:t>Primaire</a:t></a:r></a:p></a:txBody></a:tc><a:tc><a:txBody><a:bodyPr /><a:lstStyle /><a:p><a:pPr lvl="0" marL="0" indent="0" algn="l"><a:buNone /></a:pPr><a:r><a:rPr /><a:t>Nombres</a:t></a:r><a:r><a:rPr /><a:t> </a:t></a:r><a:r><a:rPr /><a:t>avec</a:t></a:r><a:r><a:rPr /><a:t> </a:t></a:r><a:r><a:rPr /><a:t>la</a:t></a:r><a:r><a:rPr /><a:t> </a:t></a:r><a:r><a:rPr /><a:t>yupana</a:t></a:r><a:r><a:rPr /><a:t> </a:t></a:r><a:r><a:rPr /><a:t>inca</a:t></a:r></a:p></a:txBody></a:tc></a:tr><a:tr h="0"><a:tc><a:txBody><a:bodyPr /><a:lstStyle /><a:p><a:pPr lvl="0" marL="0" indent="0" algn="l"><a:buNone /></a:pPr><a:r><a:rPr /><a:t>Secondaire</a:t></a:r></a:p></a:txBody></a:tc><a:tc><a:txBody><a:bodyPr /><a:lstStyle /><a:p><a:pPr lvl="0" marL="0" indent="0" algn="l"><a:buNone /></a:pPr><a:r><a:rPr /><a:t>Géométrie</a:t></a:r><a:r><a:rPr /><a:t> </a:t></a:r><a:r><a:rPr /><a:t>avec</a:t></a:r><a:r><a:rPr /><a:t> </a:t></a:r><a:r><a:rPr /><a:t>l’impression</a:t></a:r><a:r><a:rPr /><a:t> </a:t></a:r><a:r><a:rPr /><a:t>3D</a:t></a:r></a:p></a:txBody></a:tc></a:tr><a:tr h="0"><a:tc><a:txBody><a:bodyPr /><a:lstStyle /><a:p><a:pPr lvl="0" marL="0" indent="0" algn="l"><a:buNone /></a:pPr><a:r><a:rPr /><a:t>Supérieur</a:t></a:r></a:p></a:txBody></a:tc><a:tc><a:txBody><a:bodyPr /><a:lstStyle /><a:p><a:pPr lvl="0" marL="0" indent="0" algn="l"><a:buNone /></a:pPr><a:r><a:rPr /><a:t>Le</a:t></a:r><a:r><a:rPr /><a:t> </a:t></a:r><a:r><a:rPr /><a:t>raisonnement</a:t></a:r><a:r><a:rPr /><a:t> </a:t></a:r><a:r><a:rPr /><a:t>mathématique</a:t></a:r><a:r><a:rPr /><a:t> </a:t></a:r><a:r><a:rPr /><a:t>avec</a:t></a:r><a:r><a:rPr /><a:t> </a:t></a:r><a:r><a:rPr /><a:t>L</a:t></a:r><a14:m><m:oMath xmlns:m="http://schemas.openxmlformats.org/officeDocument/2006/math"><m:r><m:t>∃</m:t></m:r><m:r><m:t>∀</m:t></m:r></m:oMath></a14:m><a:r><a:rPr /><a:t>N</a:t></a:r></a:p></a:txBody></a:tc></a:tr></a:tbl></a:graphicData></a:graphic></p:graphicFrame></p:spTree></p:cSld></p:sld>
+<p:sld xmlns:a="http://schemas.openxmlformats.org/drawingml/2006/main" xmlns:r="http://schemas.openxmlformats.org/officeDocument/2006/relationships" xmlns:p="http://schemas.openxmlformats.org/presentationml/2006/main"><p:cSld><p:spTree><p:nvGrpSpPr><p:cNvPr id="1" name="" /><p:cNvGrpSpPr /><p:nvPr /></p:nvGrpSpPr><p:grpSpPr><a:xfrm><a:off x="0" y="0" /><a:ext cx="0" cy="0" /><a:chOff x="0" y="0" /><a:chExt cx="0" cy="0" /></a:xfrm></p:grpSpPr><p:graphicFrame><p:nvGraphicFramePr><p:cNvPr id="6" name="Content Placeholder 5" /><p:cNvGraphicFramePr><a:graphicFrameLocks noGrp="1" /></p:cNvGraphicFramePr><p:nvPr><p:ph idx="1" /></p:nvPr></p:nvGraphicFramePr><p:xfrm><a:off x="457200" y="1600200" /><a:ext cx="8229600" cy="4521200" /></p:xfrm><a:graphic><a:graphicData uri="http://schemas.openxmlformats.org/drawingml/2006/table"><a:tbl><a:tblPr firstRow="1" bandRow="1"><a:tableStyleId>{5C22544A-7EE6-4342-B048-85BDC9FD1C3A}</a:tableStyleId></a:tblPr><a:tblGrid><a:gridCol w="4114800" /><a:gridCol w="4114800" /></a:tblGrid><a:tr h="0"><a:tc><a:txBody><a:bodyPr /><a:lstStyle /><a:p><a:pPr lvl="0" marL="0" indent="0" algn="l"><a:buNone /></a:pPr><a:r><a:rPr /><a:t>Primaire</a:t></a:r></a:p></a:txBody></a:tc><a:tc><a:txBody><a:bodyPr /><a:lstStyle /><a:p><a:pPr lvl="0" marL="0" indent="0" algn="l"><a:buNone /></a:pPr><a:r><a:rPr /><a:t>Nombres</a:t></a:r><a:r><a:rPr /><a:t> </a:t></a:r><a:r><a:rPr /><a:t>avec</a:t></a:r><a:r><a:rPr /><a:t> </a:t></a:r><a:r><a:rPr /><a:t>la</a:t></a:r><a:r><a:rPr /><a:t> </a:t></a:r><a:r><a:rPr /><a:t>yupana</a:t></a:r><a:r><a:rPr /><a:t> </a:t></a:r><a:r><a:rPr /><a:t>Inca</a:t></a:r></a:p></a:txBody></a:tc></a:tr><a:tr h="0"><a:tc><a:txBody><a:bodyPr /><a:lstStyle /><a:p><a:pPr lvl="0" marL="0" indent="0" algn="l"><a:buNone /></a:pPr><a:r><a:rPr /><a:t>Secondaire</a:t></a:r></a:p></a:txBody></a:tc><a:tc><a:txBody><a:bodyPr /><a:lstStyle /><a:p><a:pPr lvl="0" marL="0" indent="0" algn="l"><a:buNone /></a:pPr><a:r><a:rPr /><a:t>Géométrie</a:t></a:r><a:r><a:rPr /><a:t> </a:t></a:r><a:r><a:rPr /><a:t>avec</a:t></a:r><a:r><a:rPr /><a:t> </a:t></a:r><a:r><a:rPr /><a:t>l’impression</a:t></a:r><a:r><a:rPr /><a:t> </a:t></a:r><a:r><a:rPr /><a:t>3D</a:t></a:r></a:p></a:txBody></a:tc></a:tr><a:tr h="0"><a:tc><a:txBody><a:bodyPr /><a:lstStyle /><a:p><a:pPr lvl="0" marL="0" indent="0" algn="l"><a:buNone /></a:pPr><a:r><a:rPr /><a:t>Supérieur</a:t></a:r></a:p></a:txBody></a:tc><a:tc><a:txBody><a:bodyPr /><a:lstStyle /><a:p><a:pPr lvl="0" marL="0" indent="0" algn="l"><a:buNone /></a:pPr><a:r><a:rPr /><a:t>Le</a:t></a:r><a:r><a:rPr /><a:t> </a:t></a:r><a:r><a:rPr /><a:t>raisonnement</a:t></a:r><a:r><a:rPr /><a:t> </a:t></a:r><a:r><a:rPr /><a:t>mathématique</a:t></a:r><a:r><a:rPr /><a:t> </a:t></a:r><a:r><a:rPr /><a:t>avec</a:t></a:r><a:r><a:rPr /><a:t> </a:t></a:r><a:r><a:rPr /><a:t>L</a:t></a:r><a14:m><m:oMath xmlns:m="http://schemas.openxmlformats.org/officeDocument/2006/math"><m:r><m:t>∃</m:t></m:r><m:r><m:t>∀</m:t></m:r></m:oMath></a14:m><a:r><a:rPr /><a:t>N</a:t></a:r></a:p></a:txBody></a:tc></a:tr></a:tbl></a:graphicData></a:graphic></p:graphicFrame></p:spTree></p:cSld></p:sld>
 </file>
 
 <file path=ppt/slides/slide2.xml><?xml version="1.0" encoding="utf-8"?>
@@ -4797,7 +4843,7 @@
             </a:pPr>
             <a:r>
               <a:rPr/>
-              <a:t>pourraient bénéficier d’une collaboration dans Sfere au-delà de l’ADEF, par exemple avec l’I2M et l’IREM de Marseille.</a:t>
+              <a:t>peuvent bénéficier d’une collaboration dans Sfere au-delà de l’ADEF, en particulier avec l’I2M et l’IREM de Marseille.</a:t>
             </a:r>
           </a:p>
         </p:txBody>
@@ -4899,7 +4945,7 @@
             <a:pPr lvl="2"/>
             <a:r>
               <a:rPr/>
-              <a:t>suite du projet 1.3. cartographie de la relation entre l’éducation, la médiation, les expériences artistique et scientifique et le développement de la personne, 2018</a:t>
+              <a:t>suite d’un projet de Sfere: cartographie de la relation entre l’éducation, la médiation, les expériences artistique et scientifique et le développement de la personne, 2018</a:t>
             </a:r>
           </a:p>
           <a:p>
@@ -5483,7 +5529,7 @@
 </file>
 
 <file path=ppt/slides/slide3.xml><?xml version="1.0" encoding="UTF-8"?>
-<p:sld xmlns:a="http://schemas.openxmlformats.org/drawingml/2006/main" xmlns:r="http://schemas.openxmlformats.org/officeDocument/2006/relationships" xmlns:p="http://schemas.openxmlformats.org/presentationml/2006/main"><p:cSld><p:spTree><p:nvGrpSpPr><p:cNvPr id="1" name="" /><p:cNvGrpSpPr /><p:nvPr /></p:nvGrpSpPr><p:grpSpPr><a:xfrm><a:off x="0" y="0" /><a:ext cx="0" cy="0" /><a:chOff x="0" y="0" /><a:chExt cx="0" cy="0" /></a:xfrm></p:grpSpPr><p:graphicFrame><p:nvGraphicFramePr><p:cNvPr id="6" name="Content Placeholder 5" /><p:cNvGraphicFramePr><a:graphicFrameLocks noGrp="1" /></p:cNvGraphicFramePr><p:nvPr><p:ph idx="1" /></p:nvPr></p:nvGraphicFramePr><p:xfrm><a:off x="457200" y="1600200" /><a:ext cx="8229600" cy="4521200" /></p:xfrm><a:graphic><a:graphicData uri="http://schemas.openxmlformats.org/drawingml/2006/table"><a:tbl><a:tblPr firstRow="1" bandRow="1"><a:tableStyleId>{5C22544A-7EE6-4342-B048-85BDC9FD1C3A}</a:tableStyleId></a:tblPr><a:tblGrid><a:gridCol w="4114800" /><a:gridCol w="4114800" /></a:tblGrid><a:tr h="0"><a:tc><a:txBody><a:bodyPr /><a:lstStyle /><a:p><a:pPr lvl="0" marL="0" indent="0" algn="l"><a:buNone /></a:pPr><a:r><a:rPr /><a:t>Primaire</a:t></a:r></a:p></a:txBody></a:tc><a:tc><a:txBody><a:bodyPr /><a:lstStyle /><a:p><a:pPr lvl="0" marL="0" indent="0" algn="l"><a:buNone /></a:pPr><a:r><a:rPr /><a:t>Nombres</a:t></a:r><a:r><a:rPr /><a:t> </a:t></a:r><a:r><a:rPr /><a:t>avec</a:t></a:r><a:r><a:rPr /><a:t> </a:t></a:r><a:r><a:rPr /><a:t>la</a:t></a:r><a:r><a:rPr /><a:t> </a:t></a:r><a:r><a:rPr /><a:t>yupana</a:t></a:r><a:r><a:rPr /><a:t> </a:t></a:r><a:r><a:rPr /><a:t>inca</a:t></a:r></a:p></a:txBody></a:tc></a:tr><a:tr h="0"><a:tc><a:txBody><a:bodyPr /><a:lstStyle /><a:p><a:pPr lvl="0" marL="0" indent="0" algn="l"><a:buNone /></a:pPr><a:r><a:rPr /><a:t>Secondaire</a:t></a:r></a:p></a:txBody></a:tc><a:tc><a:txBody><a:bodyPr /><a:lstStyle /><a:p><a:pPr lvl="0" marL="0" indent="0" algn="l"><a:buNone /></a:pPr><a:r><a:rPr /><a:t>Géométrie</a:t></a:r><a:r><a:rPr /><a:t> </a:t></a:r><a:r><a:rPr /><a:t>avec</a:t></a:r><a:r><a:rPr /><a:t> </a:t></a:r><a:r><a:rPr /><a:t>l’impression</a:t></a:r><a:r><a:rPr /><a:t> </a:t></a:r><a:r><a:rPr /><a:t>3D</a:t></a:r></a:p></a:txBody></a:tc></a:tr><a:tr h="0"><a:tc><a:txBody><a:bodyPr /><a:lstStyle /><a:p><a:pPr lvl="0" marL="0" indent="0" algn="l"><a:buNone /></a:pPr><a:r><a:rPr /><a:t>Supérieur</a:t></a:r></a:p></a:txBody></a:tc><a:tc><a:txBody><a:bodyPr /><a:lstStyle /><a:p><a:pPr lvl="0" marL="0" indent="0" algn="l"><a:buNone /></a:pPr><a:r><a:rPr /><a:t>Le</a:t></a:r><a:r><a:rPr /><a:t> </a:t></a:r><a:r><a:rPr /><a:t>raisonnement</a:t></a:r><a:r><a:rPr /><a:t> </a:t></a:r><a:r><a:rPr /><a:t>mathématique</a:t></a:r><a:r><a:rPr /><a:t> </a:t></a:r><a:r><a:rPr /><a:t>avec</a:t></a:r><a:r><a:rPr /><a:t> </a:t></a:r><a:r><a:rPr /><a:t>L</a:t></a:r><a14:m><m:oMath xmlns:m="http://schemas.openxmlformats.org/officeDocument/2006/math"><m:r><m:t>∃</m:t></m:r><m:r><m:t>∀</m:t></m:r></m:oMath></a14:m><a:r><a:rPr /><a:t>N</a:t></a:r></a:p></a:txBody></a:tc></a:tr></a:tbl></a:graphicData></a:graphic></p:graphicFrame></p:spTree></p:cSld></p:sld>
+<p:sld xmlns:a="http://schemas.openxmlformats.org/drawingml/2006/main" xmlns:r="http://schemas.openxmlformats.org/officeDocument/2006/relationships" xmlns:p="http://schemas.openxmlformats.org/presentationml/2006/main"><p:cSld><p:spTree><p:nvGrpSpPr><p:cNvPr id="1" name="" /><p:cNvGrpSpPr /><p:nvPr /></p:nvGrpSpPr><p:grpSpPr><a:xfrm><a:off x="0" y="0" /><a:ext cx="0" cy="0" /><a:chOff x="0" y="0" /><a:chExt cx="0" cy="0" /></a:xfrm></p:grpSpPr><p:graphicFrame><p:nvGraphicFramePr><p:cNvPr id="6" name="Content Placeholder 5" /><p:cNvGraphicFramePr><a:graphicFrameLocks noGrp="1" /></p:cNvGraphicFramePr><p:nvPr><p:ph idx="1" /></p:nvPr></p:nvGraphicFramePr><p:xfrm><a:off x="457200" y="1600200" /><a:ext cx="8229600" cy="4521200" /></p:xfrm><a:graphic><a:graphicData uri="http://schemas.openxmlformats.org/drawingml/2006/table"><a:tbl><a:tblPr firstRow="1" bandRow="1"><a:tableStyleId>{5C22544A-7EE6-4342-B048-85BDC9FD1C3A}</a:tableStyleId></a:tblPr><a:tblGrid><a:gridCol w="4114800" /><a:gridCol w="4114800" /></a:tblGrid><a:tr h="0"><a:tc><a:txBody><a:bodyPr /><a:lstStyle /><a:p><a:pPr lvl="0" marL="0" indent="0" algn="l"><a:buNone /></a:pPr><a:r><a:rPr /><a:t>Primaire</a:t></a:r></a:p></a:txBody></a:tc><a:tc><a:txBody><a:bodyPr /><a:lstStyle /><a:p><a:pPr lvl="0" marL="0" indent="0" algn="l"><a:buNone /></a:pPr><a:r><a:rPr /><a:t>Nombres</a:t></a:r><a:r><a:rPr /><a:t> </a:t></a:r><a:r><a:rPr /><a:t>avec</a:t></a:r><a:r><a:rPr /><a:t> </a:t></a:r><a:r><a:rPr /><a:t>la</a:t></a:r><a:r><a:rPr /><a:t> </a:t></a:r><a:r><a:rPr /><a:t>yupana</a:t></a:r><a:r><a:rPr /><a:t> </a:t></a:r><a:r><a:rPr /><a:t>Inca</a:t></a:r></a:p></a:txBody></a:tc></a:tr><a:tr h="0"><a:tc><a:txBody><a:bodyPr /><a:lstStyle /><a:p><a:pPr lvl="0" marL="0" indent="0" algn="l"><a:buNone /></a:pPr><a:r><a:rPr /><a:t>Secondaire</a:t></a:r></a:p></a:txBody></a:tc><a:tc><a:txBody><a:bodyPr /><a:lstStyle /><a:p><a:pPr lvl="0" marL="0" indent="0" algn="l"><a:buNone /></a:pPr><a:r><a:rPr /><a:t>Géométrie</a:t></a:r><a:r><a:rPr /><a:t> </a:t></a:r><a:r><a:rPr /><a:t>avec</a:t></a:r><a:r><a:rPr /><a:t> </a:t></a:r><a:r><a:rPr /><a:t>l’impression</a:t></a:r><a:r><a:rPr /><a:t> </a:t></a:r><a:r><a:rPr /><a:t>3D</a:t></a:r></a:p></a:txBody></a:tc></a:tr><a:tr h="0"><a:tc><a:txBody><a:bodyPr /><a:lstStyle /><a:p><a:pPr lvl="0" marL="0" indent="0" algn="l"><a:buNone /></a:pPr><a:r><a:rPr /><a:t>Supérieur</a:t></a:r></a:p></a:txBody></a:tc><a:tc><a:txBody><a:bodyPr /><a:lstStyle /><a:p><a:pPr lvl="0" marL="0" indent="0" algn="l"><a:buNone /></a:pPr><a:r><a:rPr /><a:t>Le</a:t></a:r><a:r><a:rPr /><a:t> </a:t></a:r><a:r><a:rPr /><a:t>raisonnement</a:t></a:r><a:r><a:rPr /><a:t> </a:t></a:r><a:r><a:rPr /><a:t>mathématique</a:t></a:r><a:r><a:rPr /><a:t> </a:t></a:r><a:r><a:rPr /><a:t>avec</a:t></a:r><a:r><a:rPr /><a:t> </a:t></a:r><a:r><a:rPr /><a:t>L</a:t></a:r><a14:m><m:oMath xmlns:m="http://schemas.openxmlformats.org/officeDocument/2006/math"><m:r><m:t>∃</m:t></m:r><m:r><m:t>∀</m:t></m:r></m:oMath></a14:m><a:r><a:rPr /><a:t>N</a:t></a:r></a:p></a:txBody></a:tc></a:tr></a:tbl></a:graphicData></a:graphic></p:graphicFrame></p:spTree></p:cSld></p:sld>
 </file>
 
 <file path=ppt/slides/slide4.xml><?xml version="1.0" encoding="utf-8"?>

</xml_diff>

<commit_message>
add example picturefor LEAN
</commit_message>
<xml_diff>
--- a/2020-06-01.pptx
+++ b/2020-06-01.pptx
@@ -3283,23 +3283,7 @@
             </a:pPr>
             <a:r>
               <a:rPr/>
-              <a:t>2</a:t>
-            </a:r>
-            <a:r>
-              <a:rPr/>
-              <a:t> </a:t>
-            </a:r>
-            <a:r>
-              <a:rPr/>
-              <a:t>juin</a:t>
-            </a:r>
-            <a:r>
-              <a:rPr/>
-              <a:t> </a:t>
-            </a:r>
-            <a:r>
-              <a:rPr/>
-              <a:t>2020</a:t>
+              <a:t>2020-06-02</a:t>
             </a:r>
           </a:p>
         </p:txBody>
@@ -3636,7 +3620,16 @@
             <a:pPr lvl="1"/>
             <a:r>
               <a:rPr/>
-              <a:t>approche scientifique Formation interdisciplinaire donc équilibre entre:</a:t>
+              <a:t>approche scientifique</a:t>
+            </a:r>
+          </a:p>
+          <a:p>
+            <a:pPr lvl="0" marL="0" indent="0">
+              <a:buNone/>
+            </a:pPr>
+            <a:r>
+              <a:rPr/>
+              <a:t>Formation interdisciplinaire donc équilibre entre:</a:t>
             </a:r>
           </a:p>
           <a:p>
@@ -5902,7 +5895,7 @@
                 </a14:m>
                 <a:r>
                   <a:rPr/>
-                  <a:t>N: un assistant de preuves (prononcer «linne»)</a:t>
+                  <a:t>N: un assistant de preuves (LEAN)</a:t>
                 </a:r>
               </a:p>
               <a:p>
@@ -5929,6 +5922,20 @@
                 <a:r>
                   <a:rPr/>
                   <a:t>prof d’université en mathématiques à Orsay</a:t>
+                </a:r>
+              </a:p>
+              <a:p>
+                <a:pPr lvl="0" marL="0" indent="0">
+                  <a:buNone/>
+                </a:pPr>
+              </a:p>
+              <a:p>
+                <a:pPr lvl="0" marL="0" indent="0">
+                  <a:buNone/>
+                </a:pPr>
+                <a:r>
+                  <a:rPr/>
+                  <a:t>Exemple de preuve rédigée sur papier</a:t>
                 </a:r>
               </a:p>
             </p:txBody>

</xml_diff>

<commit_message>
get rid of section title pages
</commit_message>
<xml_diff>
--- a/2020-06-01.pptx
+++ b/2020-06-01.pptx
@@ -32,6 +32,7 @@
     <p:sldId id="280" r:id="rId26"/>
     <p:sldId id="281" r:id="rId27"/>
     <p:sldId id="282" r:id="rId28"/>
+    <p:sldId id="283" r:id="rId29"/>
   </p:sldIdLst>
   <p:sldSz cx="9144000" cy="6858000" type="screen4x3"/>
   <p:notesSz cx="6858000" cy="9144000"/>
@@ -5159,19 +5160,61 @@
             </a:pPr>
             <a:r>
               <a:rPr/>
-              <a:t>Pour</a:t>
-            </a:r>
-            <a:r>
-              <a:rPr/>
-              <a:t> </a:t>
-            </a:r>
-            <a:r>
-              <a:rPr/>
-              <a:t>conclure…</a:t>
-            </a:r>
-          </a:p>
-        </p:txBody>
-      </p:sp>
+              <a:t>Conclusion</a:t>
+            </a:r>
+          </a:p>
+        </p:txBody>
+      </p:sp>
+      <p:sp>
+        <p:nvSpPr>
+          <p:cNvPr id="3" name="Content Placeholder 2"/>
+          <p:cNvSpPr>
+            <a:spLocks noGrp="1"/>
+          </p:cNvSpPr>
+          <p:nvPr>
+            <p:ph idx="1"/>
+          </p:nvPr>
+        </p:nvSpPr>
+        <p:spPr/>
+        <p:txBody>
+          <a:bodyPr/>
+          <a:lstStyle/>
+          <a:p>
+            <a:pPr lvl="0" marL="0" indent="0">
+              <a:spcBef>
+                <a:spcPts val="3000"/>
+              </a:spcBef>
+              <a:buNone/>
+            </a:pPr>
+            <a:r>
+              <a:rPr b="1"/>
+              <a:t>Pour conclure…</a:t>
+            </a:r>
+          </a:p>
+        </p:txBody>
+      </p:sp>
+    </p:spTree>
+  </p:cSld>
+</p:sld>
+</file>
+
+<file path=ppt/slides/slide26.xml><?xml version="1.0" encoding="utf-8"?>
+<p:sld xmlns:a="http://schemas.openxmlformats.org/drawingml/2006/main" xmlns:r="http://schemas.openxmlformats.org/officeDocument/2006/relationships" xmlns:p="http://schemas.openxmlformats.org/presentationml/2006/main">
+  <p:cSld>
+    <p:spTree>
+      <p:nvGrpSpPr>
+        <p:cNvPr id="1" name=""/>
+        <p:cNvGrpSpPr/>
+        <p:nvPr/>
+      </p:nvGrpSpPr>
+      <p:grpSpPr>
+        <a:xfrm>
+          <a:off x="0" y="0"/>
+          <a:ext cx="0" cy="0"/>
+          <a:chOff x="0" y="0"/>
+          <a:chExt cx="0" cy="0"/>
+        </a:xfrm>
+      </p:grpSpPr>
       <p:graphicFrame>
         <p:nvGraphicFramePr>
           <p:cNvPr id="6" name="Content Placeholder 5"/>
@@ -5436,7 +5479,7 @@
 </p:sld>
 </file>
 
-<file path=ppt/slides/slide26.xml><?xml version="1.0" encoding="utf-8"?>
+<file path=ppt/slides/slide27.xml><?xml version="1.0" encoding="utf-8"?>
 <p:sld xmlns:a="http://schemas.openxmlformats.org/drawingml/2006/main" xmlns:r="http://schemas.openxmlformats.org/officeDocument/2006/relationships" xmlns:p="http://schemas.openxmlformats.org/presentationml/2006/main">
   <p:cSld>
     <p:spTree>
@@ -5483,7 +5526,7 @@
 </p:sld>
 </file>
 
-<file path=ppt/slides/slide27.xml><?xml version="1.0" encoding="utf-8"?>
+<file path=ppt/slides/slide28.xml><?xml version="1.0" encoding="utf-8"?>
 <p:sld xmlns:a="http://schemas.openxmlformats.org/drawingml/2006/main" xmlns:r="http://schemas.openxmlformats.org/officeDocument/2006/relationships" xmlns:p="http://schemas.openxmlformats.org/presentationml/2006/main">
   <p:cSld>
     <p:spTree>

</xml_diff>

<commit_message>
Improve description of the Inca's Yupana
</commit_message>
<xml_diff>
--- a/2020-06-01.pptx
+++ b/2020-06-01.pptx
@@ -4697,7 +4697,7 @@
 </file>
 
 <file path=ppt/slides/slide19.xml><?xml version="1.0" encoding="UTF-8"?>
-<p:sld xmlns:a="http://schemas.openxmlformats.org/drawingml/2006/main" xmlns:r="http://schemas.openxmlformats.org/officeDocument/2006/relationships" xmlns:p="http://schemas.openxmlformats.org/presentationml/2006/main"><p:cSld><p:spTree><p:nvGrpSpPr><p:cNvPr id="1" name="" /><p:cNvGrpSpPr /><p:nvPr /></p:nvGrpSpPr><p:grpSpPr><a:xfrm><a:off x="0" y="0" /><a:ext cx="0" cy="0" /><a:chOff x="0" y="0" /><a:chExt cx="0" cy="0" /></a:xfrm></p:grpSpPr><p:graphicFrame><p:nvGraphicFramePr><p:cNvPr id="6" name="Content Placeholder 5" /><p:cNvGraphicFramePr><a:graphicFrameLocks noGrp="1" /></p:cNvGraphicFramePr><p:nvPr><p:ph idx="1" /></p:nvPr></p:nvGraphicFramePr><p:xfrm><a:off x="457200" y="1600200" /><a:ext cx="8229600" cy="4521200" /></p:xfrm><a:graphic><a:graphicData uri="http://schemas.openxmlformats.org/drawingml/2006/table"><a:tbl><a:tblPr firstRow="1" bandRow="1"><a:tableStyleId>{5C22544A-7EE6-4342-B048-85BDC9FD1C3A}</a:tableStyleId></a:tblPr><a:tblGrid><a:gridCol w="4114800" /><a:gridCol w="4114800" /></a:tblGrid><a:tr h="0"><a:tc><a:txBody><a:bodyPr /><a:lstStyle /><a:p><a:pPr lvl="0" marL="0" indent="0" algn="l"><a:buNone /></a:pPr><a:r><a:rPr /><a:t>Primaire</a:t></a:r></a:p></a:txBody></a:tc><a:tc><a:txBody><a:bodyPr /><a:lstStyle /><a:p><a:pPr lvl="0" marL="0" indent="0" algn="l"><a:buNone /></a:pPr><a:r><a:rPr /><a:t>Nombres</a:t></a:r><a:r><a:rPr /><a:t> </a:t></a:r><a:r><a:rPr /><a:t>avec</a:t></a:r><a:r><a:rPr /><a:t> </a:t></a:r><a:r><a:rPr /><a:t>la</a:t></a:r><a:r><a:rPr /><a:t> </a:t></a:r><a:r><a:rPr /><a:t>yupana</a:t></a:r><a:r><a:rPr /><a:t> </a:t></a:r><a:r><a:rPr /><a:t>Inca</a:t></a:r></a:p></a:txBody></a:tc></a:tr><a:tr h="0"><a:tc><a:txBody><a:bodyPr /><a:lstStyle /><a:p><a:pPr lvl="0" marL="0" indent="0" algn="l"><a:buNone /></a:pPr><a:r><a:rPr /><a:t>Secondaire</a:t></a:r></a:p></a:txBody></a:tc><a:tc><a:txBody><a:bodyPr /><a:lstStyle /><a:p><a:pPr lvl="0" marL="0" indent="0" algn="l"><a:buNone /></a:pPr><a:r><a:rPr /><a:t>Géométrie</a:t></a:r><a:r><a:rPr /><a:t> </a:t></a:r><a:r><a:rPr /><a:t>avec</a:t></a:r><a:r><a:rPr /><a:t> </a:t></a:r><a:r><a:rPr /><a:t>l’impression</a:t></a:r><a:r><a:rPr /><a:t> </a:t></a:r><a:r><a:rPr /><a:t>3D</a:t></a:r></a:p></a:txBody></a:tc></a:tr><a:tr h="0"><a:tc><a:txBody><a:bodyPr /><a:lstStyle /><a:p><a:pPr lvl="0" marL="0" indent="0" algn="l"><a:buNone /></a:pPr><a:r><a:rPr /><a:t>Supérieur</a:t></a:r></a:p></a:txBody></a:tc><a:tc><a:txBody><a:bodyPr /><a:lstStyle /><a:p><a:pPr lvl="0" marL="0" indent="0" algn="l"><a:buNone /></a:pPr><a:r><a:rPr /><a:t>Le</a:t></a:r><a:r><a:rPr /><a:t> </a:t></a:r><a:r><a:rPr /><a:t>raisonnement</a:t></a:r><a:r><a:rPr /><a:t> </a:t></a:r><a:r><a:rPr /><a:t>mathématique</a:t></a:r><a:r><a:rPr /><a:t> </a:t></a:r><a:r><a:rPr /><a:t>avec</a:t></a:r><a:r><a:rPr /><a:t> </a:t></a:r><a:r><a:rPr /><a:t>L</a:t></a:r><a14:m><m:oMath xmlns:m="http://schemas.openxmlformats.org/officeDocument/2006/math"><m:r><m:t>∃</m:t></m:r><m:r><m:t>∀</m:t></m:r></m:oMath></a14:m><a:r><a:rPr /><a:t>N</a:t></a:r></a:p></a:txBody></a:tc></a:tr></a:tbl></a:graphicData></a:graphic></p:graphicFrame></p:spTree></p:cSld></p:sld>
+<p:sld xmlns:a="http://schemas.openxmlformats.org/drawingml/2006/main" xmlns:r="http://schemas.openxmlformats.org/officeDocument/2006/relationships" xmlns:p="http://schemas.openxmlformats.org/presentationml/2006/main"><p:cSld><p:spTree><p:nvGrpSpPr><p:cNvPr id="1" name="" /><p:cNvGrpSpPr /><p:nvPr /></p:nvGrpSpPr><p:grpSpPr><a:xfrm><a:off x="0" y="0" /><a:ext cx="0" cy="0" /><a:chOff x="0" y="0" /><a:chExt cx="0" cy="0" /></a:xfrm></p:grpSpPr><p:graphicFrame><p:nvGraphicFramePr><p:cNvPr id="6" name="Content Placeholder 5" /><p:cNvGraphicFramePr><a:graphicFrameLocks noGrp="1" /></p:cNvGraphicFramePr><p:nvPr><p:ph idx="1" /></p:nvPr></p:nvGraphicFramePr><p:xfrm><a:off x="457200" y="1600200" /><a:ext cx="8229600" cy="4521200" /></p:xfrm><a:graphic><a:graphicData uri="http://schemas.openxmlformats.org/drawingml/2006/table"><a:tbl><a:tblPr firstRow="1" bandRow="1"><a:tableStyleId>{5C22544A-7EE6-4342-B048-85BDC9FD1C3A}</a:tableStyleId></a:tblPr><a:tblGrid><a:gridCol w="4114800" /><a:gridCol w="4114800" /></a:tblGrid><a:tr h="0"><a:tc><a:txBody><a:bodyPr /><a:lstStyle /><a:p><a:pPr lvl="0" marL="0" indent="0" algn="l"><a:buNone /></a:pPr><a:r><a:rPr /><a:t>Primaire</a:t></a:r></a:p></a:txBody></a:tc><a:tc><a:txBody><a:bodyPr /><a:lstStyle /><a:p><a:pPr lvl="0" marL="0" indent="0" algn="l"><a:buNone /></a:pPr><a:r><a:rPr /><a:t>Nombres</a:t></a:r><a:r><a:rPr /><a:t> </a:t></a:r><a:r><a:rPr /><a:t>avec</a:t></a:r><a:r><a:rPr /><a:t> </a:t></a:r><a:r><a:rPr /><a:t>la</a:t></a:r><a:r><a:rPr /><a:t> </a:t></a:r><a:r><a:rPr /><a:t>yupana</a:t></a:r><a:r><a:rPr /><a:t> </a:t></a:r><a:r><a:rPr /><a:t>inca</a:t></a:r></a:p></a:txBody></a:tc></a:tr><a:tr h="0"><a:tc><a:txBody><a:bodyPr /><a:lstStyle /><a:p><a:pPr lvl="0" marL="0" indent="0" algn="l"><a:buNone /></a:pPr><a:r><a:rPr /><a:t>Secondaire</a:t></a:r></a:p></a:txBody></a:tc><a:tc><a:txBody><a:bodyPr /><a:lstStyle /><a:p><a:pPr lvl="0" marL="0" indent="0" algn="l"><a:buNone /></a:pPr><a:r><a:rPr /><a:t>Géométrie</a:t></a:r><a:r><a:rPr /><a:t> </a:t></a:r><a:r><a:rPr /><a:t>avec</a:t></a:r><a:r><a:rPr /><a:t> </a:t></a:r><a:r><a:rPr /><a:t>l’impression</a:t></a:r><a:r><a:rPr /><a:t> </a:t></a:r><a:r><a:rPr /><a:t>3D</a:t></a:r></a:p></a:txBody></a:tc></a:tr><a:tr h="0"><a:tc><a:txBody><a:bodyPr /><a:lstStyle /><a:p><a:pPr lvl="0" marL="0" indent="0" algn="l"><a:buNone /></a:pPr><a:r><a:rPr /><a:t>Supérieur</a:t></a:r></a:p></a:txBody></a:tc><a:tc><a:txBody><a:bodyPr /><a:lstStyle /><a:p><a:pPr lvl="0" marL="0" indent="0" algn="l"><a:buNone /></a:pPr><a:r><a:rPr /><a:t>Le</a:t></a:r><a:r><a:rPr /><a:t> </a:t></a:r><a:r><a:rPr /><a:t>raisonnement</a:t></a:r><a:r><a:rPr /><a:t> </a:t></a:r><a:r><a:rPr /><a:t>mathématique</a:t></a:r><a:r><a:rPr /><a:t> </a:t></a:r><a:r><a:rPr /><a:t>avec</a:t></a:r><a:r><a:rPr /><a:t> </a:t></a:r><a:r><a:rPr /><a:t>L</a:t></a:r><a14:m><m:oMath xmlns:m="http://schemas.openxmlformats.org/officeDocument/2006/math"><m:r><m:t>∃</m:t></m:r><m:r><m:t>∀</m:t></m:r></m:oMath></a14:m><a:r><a:rPr /><a:t>N</a:t></a:r></a:p></a:txBody></a:tc></a:tr></a:tbl></a:graphicData></a:graphic></p:graphicFrame></p:spTree></p:cSld></p:sld>
 </file>
 
 <file path=ppt/slides/slide2.xml><?xml version="1.0" encoding="utf-8"?>
@@ -5579,7 +5579,7 @@
 </file>
 
 <file path=ppt/slides/slide3.xml><?xml version="1.0" encoding="UTF-8"?>
-<p:sld xmlns:a="http://schemas.openxmlformats.org/drawingml/2006/main" xmlns:r="http://schemas.openxmlformats.org/officeDocument/2006/relationships" xmlns:p="http://schemas.openxmlformats.org/presentationml/2006/main"><p:cSld><p:spTree><p:nvGrpSpPr><p:cNvPr id="1" name="" /><p:cNvGrpSpPr /><p:nvPr /></p:nvGrpSpPr><p:grpSpPr><a:xfrm><a:off x="0" y="0" /><a:ext cx="0" cy="0" /><a:chOff x="0" y="0" /><a:chExt cx="0" cy="0" /></a:xfrm></p:grpSpPr><p:graphicFrame><p:nvGraphicFramePr><p:cNvPr id="6" name="Content Placeholder 5" /><p:cNvGraphicFramePr><a:graphicFrameLocks noGrp="1" /></p:cNvGraphicFramePr><p:nvPr><p:ph idx="1" /></p:nvPr></p:nvGraphicFramePr><p:xfrm><a:off x="457200" y="1600200" /><a:ext cx="8229600" cy="4521200" /></p:xfrm><a:graphic><a:graphicData uri="http://schemas.openxmlformats.org/drawingml/2006/table"><a:tbl><a:tblPr firstRow="1" bandRow="1"><a:tableStyleId>{5C22544A-7EE6-4342-B048-85BDC9FD1C3A}</a:tableStyleId></a:tblPr><a:tblGrid><a:gridCol w="4114800" /><a:gridCol w="4114800" /></a:tblGrid><a:tr h="0"><a:tc><a:txBody><a:bodyPr /><a:lstStyle /><a:p><a:pPr lvl="0" marL="0" indent="0" algn="l"><a:buNone /></a:pPr><a:r><a:rPr /><a:t>Primaire</a:t></a:r></a:p></a:txBody></a:tc><a:tc><a:txBody><a:bodyPr /><a:lstStyle /><a:p><a:pPr lvl="0" marL="0" indent="0" algn="l"><a:buNone /></a:pPr><a:r><a:rPr /><a:t>Nombres</a:t></a:r><a:r><a:rPr /><a:t> </a:t></a:r><a:r><a:rPr /><a:t>avec</a:t></a:r><a:r><a:rPr /><a:t> </a:t></a:r><a:r><a:rPr /><a:t>la</a:t></a:r><a:r><a:rPr /><a:t> </a:t></a:r><a:r><a:rPr /><a:t>yupana</a:t></a:r><a:r><a:rPr /><a:t> </a:t></a:r><a:r><a:rPr /><a:t>Inca</a:t></a:r></a:p></a:txBody></a:tc></a:tr><a:tr h="0"><a:tc><a:txBody><a:bodyPr /><a:lstStyle /><a:p><a:pPr lvl="0" marL="0" indent="0" algn="l"><a:buNone /></a:pPr><a:r><a:rPr /><a:t>Secondaire</a:t></a:r></a:p></a:txBody></a:tc><a:tc><a:txBody><a:bodyPr /><a:lstStyle /><a:p><a:pPr lvl="0" marL="0" indent="0" algn="l"><a:buNone /></a:pPr><a:r><a:rPr /><a:t>Géométrie</a:t></a:r><a:r><a:rPr /><a:t> </a:t></a:r><a:r><a:rPr /><a:t>avec</a:t></a:r><a:r><a:rPr /><a:t> </a:t></a:r><a:r><a:rPr /><a:t>l’impression</a:t></a:r><a:r><a:rPr /><a:t> </a:t></a:r><a:r><a:rPr /><a:t>3D</a:t></a:r></a:p></a:txBody></a:tc></a:tr><a:tr h="0"><a:tc><a:txBody><a:bodyPr /><a:lstStyle /><a:p><a:pPr lvl="0" marL="0" indent="0" algn="l"><a:buNone /></a:pPr><a:r><a:rPr /><a:t>Supérieur</a:t></a:r></a:p></a:txBody></a:tc><a:tc><a:txBody><a:bodyPr /><a:lstStyle /><a:p><a:pPr lvl="0" marL="0" indent="0" algn="l"><a:buNone /></a:pPr><a:r><a:rPr /><a:t>Le</a:t></a:r><a:r><a:rPr /><a:t> </a:t></a:r><a:r><a:rPr /><a:t>raisonnement</a:t></a:r><a:r><a:rPr /><a:t> </a:t></a:r><a:r><a:rPr /><a:t>mathématique</a:t></a:r><a:r><a:rPr /><a:t> </a:t></a:r><a:r><a:rPr /><a:t>avec</a:t></a:r><a:r><a:rPr /><a:t> </a:t></a:r><a:r><a:rPr /><a:t>L</a:t></a:r><a14:m><m:oMath xmlns:m="http://schemas.openxmlformats.org/officeDocument/2006/math"><m:r><m:t>∃</m:t></m:r><m:r><m:t>∀</m:t></m:r></m:oMath></a14:m><a:r><a:rPr /><a:t>N</a:t></a:r></a:p></a:txBody></a:tc></a:tr></a:tbl></a:graphicData></a:graphic></p:graphicFrame></p:spTree></p:cSld></p:sld>
+<p:sld xmlns:a="http://schemas.openxmlformats.org/drawingml/2006/main" xmlns:r="http://schemas.openxmlformats.org/officeDocument/2006/relationships" xmlns:p="http://schemas.openxmlformats.org/presentationml/2006/main"><p:cSld><p:spTree><p:nvGrpSpPr><p:cNvPr id="1" name="" /><p:cNvGrpSpPr /><p:nvPr /></p:nvGrpSpPr><p:grpSpPr><a:xfrm><a:off x="0" y="0" /><a:ext cx="0" cy="0" /><a:chOff x="0" y="0" /><a:chExt cx="0" cy="0" /></a:xfrm></p:grpSpPr><p:graphicFrame><p:nvGraphicFramePr><p:cNvPr id="6" name="Content Placeholder 5" /><p:cNvGraphicFramePr><a:graphicFrameLocks noGrp="1" /></p:cNvGraphicFramePr><p:nvPr><p:ph idx="1" /></p:nvPr></p:nvGraphicFramePr><p:xfrm><a:off x="457200" y="1600200" /><a:ext cx="8229600" cy="4521200" /></p:xfrm><a:graphic><a:graphicData uri="http://schemas.openxmlformats.org/drawingml/2006/table"><a:tbl><a:tblPr firstRow="1" bandRow="1"><a:tableStyleId>{5C22544A-7EE6-4342-B048-85BDC9FD1C3A}</a:tableStyleId></a:tblPr><a:tblGrid><a:gridCol w="4114800" /><a:gridCol w="4114800" /></a:tblGrid><a:tr h="0"><a:tc><a:txBody><a:bodyPr /><a:lstStyle /><a:p><a:pPr lvl="0" marL="0" indent="0" algn="l"><a:buNone /></a:pPr><a:r><a:rPr /><a:t>Primaire</a:t></a:r></a:p></a:txBody></a:tc><a:tc><a:txBody><a:bodyPr /><a:lstStyle /><a:p><a:pPr lvl="0" marL="0" indent="0" algn="l"><a:buNone /></a:pPr><a:r><a:rPr /><a:t>Nombres</a:t></a:r><a:r><a:rPr /><a:t> </a:t></a:r><a:r><a:rPr /><a:t>avec</a:t></a:r><a:r><a:rPr /><a:t> </a:t></a:r><a:r><a:rPr /><a:t>la</a:t></a:r><a:r><a:rPr /><a:t> </a:t></a:r><a:r><a:rPr /><a:t>yupana</a:t></a:r><a:r><a:rPr /><a:t> </a:t></a:r><a:r><a:rPr /><a:t>inca</a:t></a:r></a:p></a:txBody></a:tc></a:tr><a:tr h="0"><a:tc><a:txBody><a:bodyPr /><a:lstStyle /><a:p><a:pPr lvl="0" marL="0" indent="0" algn="l"><a:buNone /></a:pPr><a:r><a:rPr /><a:t>Secondaire</a:t></a:r></a:p></a:txBody></a:tc><a:tc><a:txBody><a:bodyPr /><a:lstStyle /><a:p><a:pPr lvl="0" marL="0" indent="0" algn="l"><a:buNone /></a:pPr><a:r><a:rPr /><a:t>Géométrie</a:t></a:r><a:r><a:rPr /><a:t> </a:t></a:r><a:r><a:rPr /><a:t>avec</a:t></a:r><a:r><a:rPr /><a:t> </a:t></a:r><a:r><a:rPr /><a:t>l’impression</a:t></a:r><a:r><a:rPr /><a:t> </a:t></a:r><a:r><a:rPr /><a:t>3D</a:t></a:r></a:p></a:txBody></a:tc></a:tr><a:tr h="0"><a:tc><a:txBody><a:bodyPr /><a:lstStyle /><a:p><a:pPr lvl="0" marL="0" indent="0" algn="l"><a:buNone /></a:pPr><a:r><a:rPr /><a:t>Supérieur</a:t></a:r></a:p></a:txBody></a:tc><a:tc><a:txBody><a:bodyPr /><a:lstStyle /><a:p><a:pPr lvl="0" marL="0" indent="0" algn="l"><a:buNone /></a:pPr><a:r><a:rPr /><a:t>Le</a:t></a:r><a:r><a:rPr /><a:t> </a:t></a:r><a:r><a:rPr /><a:t>raisonnement</a:t></a:r><a:r><a:rPr /><a:t> </a:t></a:r><a:r><a:rPr /><a:t>mathématique</a:t></a:r><a:r><a:rPr /><a:t> </a:t></a:r><a:r><a:rPr /><a:t>avec</a:t></a:r><a:r><a:rPr /><a:t> </a:t></a:r><a:r><a:rPr /><a:t>L</a:t></a:r><a14:m><m:oMath xmlns:m="http://schemas.openxmlformats.org/officeDocument/2006/math"><m:r><m:t>∃</m:t></m:r><m:r><m:t>∀</m:t></m:r></m:oMath></a14:m><a:r><a:rPr /><a:t>N</a:t></a:r></a:p></a:txBody></a:tc></a:tr></a:tbl></a:graphicData></a:graphic></p:graphicFrame></p:spTree></p:cSld></p:sld>
 </file>
 
 <file path=ppt/slides/slide4.xml><?xml version="1.0" encoding="utf-8"?>
@@ -5622,7 +5622,7 @@
             </a:pPr>
             <a:r>
               <a:rPr b="1"/>
-              <a:t>Yupana Inca</a:t>
+              <a:t>Yupana inca</a:t>
             </a:r>
           </a:p>
           <a:p>

</xml_diff>

<commit_message>
improve table at slide 13
</commit_message>
<xml_diff>
--- a/2020-06-01.pptx
+++ b/2020-06-01.pptx
@@ -4445,28 +4445,10 @@
                         <a:rPr/>
                         <a:t>mathématiques</a:t>
                       </a:r>
-                    </a:p>
-                  </a:txBody>
-                </a:tc>
-              </a:tr>
-              <a:tr h="0">
-                <a:tc>
-                  <a:txBody>
-                    <a:bodyPr/>
-                    <a:lstStyle/>
-                    <a:p>
-                      <a:endParaRPr/>
-                    </a:p>
-                  </a:txBody>
-                </a:tc>
-                <a:tc>
-                  <a:txBody>
-                    <a:bodyPr/>
-                    <a:lstStyle/>
-                    <a:p>
-                      <a:pPr lvl="0" marL="0" indent="0">
-                        <a:buNone/>
-                      </a:pPr>
+                      <a:r>
+                        <a:rPr/>
+                        <a:t> </a:t>
+                      </a:r>
                       <a:r>
                         <a:rPr/>
                         <a:t>Intégration</a:t>

</xml_diff>

<commit_message>
rajouter la date des MOOCs
</commit_message>
<xml_diff>
--- a/2020-06-01.pptx
+++ b/2020-06-01.pptx
@@ -3432,7 +3432,7 @@
             <a:pPr lvl="1"/>
             <a:r>
               <a:rPr/>
-              <a:t>suivi deux MOOC sur l’éducation</a:t>
+              <a:t>suivi deux MOOC sur l’éducation en 2016</a:t>
             </a:r>
           </a:p>
           <a:p>
@@ -5960,7 +5960,7 @@
                 </a:pPr>
                 <a:r>
                   <a:rPr/>
-                  <a:t>Exemple de preuve rédigée sur papier</a:t>
+                  <a:t>Exemple de demonstration rédigée sur papier</a:t>
                 </a:r>
               </a:p>
             </p:txBody>

</xml_diff>

<commit_message>
add slide about AMPIRIC
</commit_message>
<xml_diff>
--- a/2020-06-01.pptx
+++ b/2020-06-01.pptx
@@ -3644,7 +3644,7 @@
             <a:pPr lvl="1"/>
             <a:r>
               <a:rPr/>
-              <a:t>former à un enseignement des mathématiques ancrée dans le monde</a:t>
+              <a:t>former à un enseignement des mathématiques ancrées dans le monde</a:t>
             </a:r>
           </a:p>
         </p:txBody>
@@ -4650,6 +4650,32 @@
         <p:txBody>
           <a:bodyPr/>
           <a:lstStyle/>
+          <a:p>
+            <a:pPr lvl="0" marL="0" indent="0">
+              <a:spcBef>
+                <a:spcPts val="3000"/>
+              </a:spcBef>
+              <a:buNone/>
+            </a:pPr>
+            <a:r>
+              <a:rPr b="1"/>
+              <a:t>AMPIRIC</a:t>
+            </a:r>
+          </a:p>
+          <a:p>
+            <a:pPr lvl="0" marL="0" indent="0">
+              <a:buNone/>
+            </a:pPr>
+          </a:p>
+          <a:p>
+            <a:pPr lvl="0" marL="0" indent="0">
+              <a:buNone/>
+            </a:pPr>
+            <a:r>
+              <a:rPr/>
+              <a:t>Extrait de la présentation d’AMPIRIC de janvier 2020 (Jacques Ginestié)</a:t>
+            </a:r>
+          </a:p>
           <a:p>
             <a:pPr lvl="0" marL="0" indent="0">
               <a:spcBef>

</xml_diff>

<commit_message>
incorpore remarques de Samuel
</commit_message>
<xml_diff>
--- a/2020-06-01.pptx
+++ b/2020-06-01.pptx
@@ -3284,7 +3284,23 @@
             </a:pPr>
             <a:r>
               <a:rPr/>
-              <a:t>2020-06-02</a:t>
+              <a:t>2</a:t>
+            </a:r>
+            <a:r>
+              <a:rPr/>
+              <a:t> </a:t>
+            </a:r>
+            <a:r>
+              <a:rPr/>
+              <a:t>juin</a:t>
+            </a:r>
+            <a:r>
+              <a:rPr/>
+              <a:t> </a:t>
+            </a:r>
+            <a:r>
+              <a:rPr/>
+              <a:t>2020</a:t>
             </a:r>
           </a:p>
         </p:txBody>
@@ -3472,7 +3488,7 @@
             <a:pPr lvl="1"/>
             <a:r>
               <a:rPr/>
-              <a:t>interactions avec des enseignants:</a:t>
+              <a:t>interactions avec des enseignants</a:t>
             </a:r>
           </a:p>
           <a:p>
@@ -3559,7 +3575,7 @@
             </a:pPr>
             <a:r>
               <a:rPr/>
-              <a:t>Trois étapes:</a:t>
+              <a:t>Trois étapes</a:t>
             </a:r>
           </a:p>
           <a:p>
@@ -3607,7 +3623,7 @@
             </a:pPr>
             <a:r>
               <a:rPr/>
-              <a:t>Formation professionnalisante donc équilibre entre:</a:t>
+              <a:t>Formation professionnalisante donc équilibre entre</a:t>
             </a:r>
           </a:p>
           <a:p>
@@ -3630,7 +3646,7 @@
             </a:pPr>
             <a:r>
               <a:rPr/>
-              <a:t>Formation interdisciplinaire donc équilibre entre:</a:t>
+              <a:t>Formation interdisciplinaire donc équilibre entre</a:t>
             </a:r>
           </a:p>
           <a:p>
@@ -3703,7 +3719,7 @@
             </a:pPr>
             <a:r>
               <a:rPr/>
-              <a:t>Collège:</a:t>
+              <a:t>Collège</a:t>
             </a:r>
           </a:p>
           <a:p>
@@ -3749,7 +3765,7 @@
             </a:pPr>
             <a:r>
               <a:rPr/>
-              <a:t>Formation professionnalisante donc équilibre entre:</a:t>
+              <a:t>Formation professionnalisante donc équilibre entre</a:t>
             </a:r>
           </a:p>
           <a:p>
@@ -3772,7 +3788,7 @@
             </a:pPr>
             <a:r>
               <a:rPr/>
-              <a:t>Formation interdisciplinaire donc équilibre entre:</a:t>
+              <a:t>Formation interdisciplinaire donc équilibre entre</a:t>
             </a:r>
           </a:p>
           <a:p>
@@ -3786,7 +3802,17 @@
             <a:pPr lvl="1"/>
             <a:r>
               <a:rPr/>
-              <a:t>former à un enseignement des mathématiques qui aident à comprendre le monde</a:t>
+              <a:t>former à un enseignement des mathématiques</a:t>
+            </a:r>
+            <a:br/>
+          </a:p>
+          <a:p>
+            <a:pPr lvl="1">
+              <a:buNone/>
+            </a:pPr>
+            <a:r>
+              <a:rPr/>
+              <a:t>qui aident à comprendre le monde</a:t>
             </a:r>
           </a:p>
         </p:txBody>
@@ -3890,7 +3916,7 @@
             </a:pPr>
             <a:r>
               <a:rPr b="1"/>
-              <a:t>Mise en relation entre mon parcours et la formation des enseignants</a:t>
+              <a:t>Liens entre mon parcours et la formation des enseignants</a:t>
             </a:r>
           </a:p>
         </p:txBody>
@@ -3952,88 +3978,6 @@
                       </a:pPr>
                       <a:r>
                         <a:rPr/>
-                        <a:t>Mon</a:t>
-                      </a:r>
-                      <a:r>
-                        <a:rPr/>
-                        <a:t> </a:t>
-                      </a:r>
-                      <a:r>
-                        <a:rPr/>
-                        <a:t>parcours</a:t>
-                      </a:r>
-                    </a:p>
-                  </a:txBody>
-                  <a:tcPr/>
-                </a:tc>
-                <a:tc>
-                  <a:txBody>
-                    <a:bodyPr/>
-                    <a:lstStyle/>
-                    <a:p>
-                      <a:pPr lvl="0" marL="0" indent="0">
-                        <a:buNone/>
-                      </a:pPr>
-                      <a:r>
-                        <a:rPr/>
-                        <a:t>Applications</a:t>
-                      </a:r>
-                      <a:r>
-                        <a:rPr/>
-                        <a:t> </a:t>
-                      </a:r>
-                      <a:r>
-                        <a:rPr/>
-                        <a:t>à</a:t>
-                      </a:r>
-                      <a:r>
-                        <a:rPr/>
-                        <a:t> </a:t>
-                      </a:r>
-                      <a:r>
-                        <a:rPr/>
-                        <a:t>la</a:t>
-                      </a:r>
-                      <a:r>
-                        <a:rPr/>
-                        <a:t> </a:t>
-                      </a:r>
-                      <a:r>
-                        <a:rPr/>
-                        <a:t>formation</a:t>
-                      </a:r>
-                      <a:r>
-                        <a:rPr/>
-                        <a:t> </a:t>
-                      </a:r>
-                      <a:r>
-                        <a:rPr/>
-                        <a:t>des</a:t>
-                      </a:r>
-                      <a:r>
-                        <a:rPr/>
-                        <a:t> </a:t>
-                      </a:r>
-                      <a:r>
-                        <a:rPr/>
-                        <a:t>enseignants</a:t>
-                      </a:r>
-                    </a:p>
-                  </a:txBody>
-                  <a:tcPr/>
-                </a:tc>
-              </a:tr>
-              <a:tr h="0">
-                <a:tc>
-                  <a:txBody>
-                    <a:bodyPr/>
-                    <a:lstStyle/>
-                    <a:p>
-                      <a:pPr lvl="0" marL="0" indent="0">
-                        <a:buNone/>
-                      </a:pPr>
-                      <a:r>
-                        <a:rPr/>
                         <a:t>Géométrie</a:t>
                       </a:r>
                       <a:r>
@@ -4131,6 +4075,26 @@
                         <a:rPr/>
                         <a:t>élèves</a:t>
                       </a:r>
+                    </a:p>
+                  </a:txBody>
+                </a:tc>
+              </a:tr>
+              <a:tr h="0">
+                <a:tc>
+                  <a:txBody>
+                    <a:bodyPr/>
+                    <a:lstStyle/>
+                    <a:p>
+                      <a:endParaRPr/>
+                    </a:p>
+                  </a:txBody>
+                </a:tc>
+                <a:tc>
+                  <a:txBody>
+                    <a:bodyPr/>
+                    <a:lstStyle/>
+                    <a:p>
+                      <a:endParaRPr/>
                     </a:p>
                   </a:txBody>
                 </a:tc>
@@ -4169,7 +4133,31 @@
                       </a:pPr>
                       <a:r>
                         <a:rPr/>
-                        <a:t>Usages</a:t>
+                        <a:t>Conception</a:t>
+                      </a:r>
+                      <a:r>
+                        <a:rPr/>
+                        <a:t> </a:t>
+                      </a:r>
+                      <a:r>
+                        <a:rPr/>
+                        <a:t>et</a:t>
+                      </a:r>
+                      <a:r>
+                        <a:rPr/>
+                        <a:t> </a:t>
+                      </a:r>
+                      <a:r>
+                        <a:rPr/>
+                        <a:t>impression</a:t>
+                      </a:r>
+                      <a:r>
+                        <a:rPr/>
+                        <a:t> </a:t>
+                      </a:r>
+                      <a:r>
+                        <a:rPr/>
+                        <a:t>3D</a:t>
                       </a:r>
                       <a:r>
                         <a:rPr/>
@@ -4187,62 +4175,26 @@
                         <a:rPr/>
                         <a:t>classe</a:t>
                       </a:r>
-                      <a:r>
-                        <a:rPr/>
-                        <a:t> </a:t>
-                      </a:r>
-                      <a:r>
-                        <a:rPr/>
-                        <a:t>de</a:t>
-                      </a:r>
-                      <a:r>
-                        <a:rPr/>
-                        <a:t> </a:t>
-                      </a:r>
-                      <a:r>
-                        <a:rPr/>
-                        <a:t>la</a:t>
-                      </a:r>
-                      <a:r>
-                        <a:rPr/>
-                        <a:t> </a:t>
-                      </a:r>
-                      <a:r>
-                        <a:rPr/>
-                        <a:t>conception</a:t>
-                      </a:r>
-                      <a:r>
-                        <a:rPr/>
-                        <a:t> </a:t>
-                      </a:r>
-                      <a:r>
-                        <a:rPr/>
-                        <a:t>et</a:t>
-                      </a:r>
-                      <a:r>
-                        <a:rPr/>
-                        <a:t> </a:t>
-                      </a:r>
-                      <a:r>
-                        <a:rPr/>
-                        <a:t>de</a:t>
-                      </a:r>
-                      <a:r>
-                        <a:rPr/>
-                        <a:t> </a:t>
-                      </a:r>
-                      <a:r>
-                        <a:rPr/>
-                        <a:t>l’impression</a:t>
-                      </a:r>
-                      <a:r>
-                        <a:rPr/>
-                        <a:t> </a:t>
-                      </a:r>
-                      <a:r>
-                        <a:rPr/>
-                        <a:t>3D</a:t>
-                      </a:r>
+                    </a:p>
+                  </a:txBody>
+                </a:tc>
+              </a:tr>
+              <a:tr h="0">
+                <a:tc>
+                  <a:txBody>
+                    <a:bodyPr/>
+                    <a:lstStyle/>
+                    <a:p>
+                      <a:endParaRPr/>
+                    </a:p>
+                  </a:txBody>
+                </a:tc>
+                <a:tc>
+                  <a:txBody>
+                    <a:bodyPr/>
+                    <a:lstStyle/>
+                    <a:p>
+                      <a:endParaRPr/>
                     </a:p>
                   </a:txBody>
                 </a:tc>
@@ -4383,6 +4335,26 @@
                     <a:bodyPr/>
                     <a:lstStyle/>
                     <a:p>
+                      <a:endParaRPr/>
+                    </a:p>
+                  </a:txBody>
+                </a:tc>
+                <a:tc>
+                  <a:txBody>
+                    <a:bodyPr/>
+                    <a:lstStyle/>
+                    <a:p>
+                      <a:endParaRPr/>
+                    </a:p>
+                  </a:txBody>
+                </a:tc>
+              </a:tr>
+              <a:tr h="0">
+                <a:tc>
+                  <a:txBody>
+                    <a:bodyPr/>
+                    <a:lstStyle/>
+                    <a:p>
                       <a:pPr lvl="0" marL="0" indent="0">
                         <a:buNone/>
                       </a:pPr>
@@ -4469,6 +4441,26 @@
                         <a:rPr/>
                         <a:t>TICE</a:t>
                       </a:r>
+                    </a:p>
+                  </a:txBody>
+                </a:tc>
+              </a:tr>
+              <a:tr h="0">
+                <a:tc>
+                  <a:txBody>
+                    <a:bodyPr/>
+                    <a:lstStyle/>
+                    <a:p>
+                      <a:endParaRPr/>
+                    </a:p>
+                  </a:txBody>
+                </a:tc>
+                <a:tc>
+                  <a:txBody>
+                    <a:bodyPr/>
+                    <a:lstStyle/>
+                    <a:p>
+                      <a:endParaRPr/>
                     </a:p>
                   </a:txBody>
                 </a:tc>
@@ -4704,8 +4696,238 @@
 </p:sld>
 </file>
 
-<file path=ppt/slides/slide19.xml><?xml version="1.0" encoding="UTF-8"?>
-<p:sld xmlns:a="http://schemas.openxmlformats.org/drawingml/2006/main" xmlns:r="http://schemas.openxmlformats.org/officeDocument/2006/relationships" xmlns:p="http://schemas.openxmlformats.org/presentationml/2006/main"><p:cSld><p:spTree><p:nvGrpSpPr><p:cNvPr id="1" name="" /><p:cNvGrpSpPr /><p:nvPr /></p:nvGrpSpPr><p:grpSpPr><a:xfrm><a:off x="0" y="0" /><a:ext cx="0" cy="0" /><a:chOff x="0" y="0" /><a:chExt cx="0" cy="0" /></a:xfrm></p:grpSpPr><p:graphicFrame><p:nvGraphicFramePr><p:cNvPr id="6" name="Content Placeholder 5" /><p:cNvGraphicFramePr><a:graphicFrameLocks noGrp="1" /></p:cNvGraphicFramePr><p:nvPr><p:ph idx="1" /></p:nvPr></p:nvGraphicFramePr><p:xfrm><a:off x="457200" y="1600200" /><a:ext cx="8229600" cy="4521200" /></p:xfrm><a:graphic><a:graphicData uri="http://schemas.openxmlformats.org/drawingml/2006/table"><a:tbl><a:tblPr firstRow="1" bandRow="1"><a:tableStyleId>{5C22544A-7EE6-4342-B048-85BDC9FD1C3A}</a:tableStyleId></a:tblPr><a:tblGrid><a:gridCol w="4114800" /><a:gridCol w="4114800" /></a:tblGrid><a:tr h="0"><a:tc><a:txBody><a:bodyPr /><a:lstStyle /><a:p><a:pPr lvl="0" marL="0" indent="0" algn="l"><a:buNone /></a:pPr><a:r><a:rPr /><a:t>Primaire</a:t></a:r></a:p></a:txBody></a:tc><a:tc><a:txBody><a:bodyPr /><a:lstStyle /><a:p><a:pPr lvl="0" marL="0" indent="0" algn="l"><a:buNone /></a:pPr><a:r><a:rPr /><a:t>Nombres</a:t></a:r><a:r><a:rPr /><a:t> </a:t></a:r><a:r><a:rPr /><a:t>avec</a:t></a:r><a:r><a:rPr /><a:t> </a:t></a:r><a:r><a:rPr /><a:t>la</a:t></a:r><a:r><a:rPr /><a:t> </a:t></a:r><a:r><a:rPr /><a:t>yupana</a:t></a:r><a:r><a:rPr /><a:t> </a:t></a:r><a:r><a:rPr /><a:t>inca</a:t></a:r></a:p></a:txBody></a:tc></a:tr><a:tr h="0"><a:tc><a:txBody><a:bodyPr /><a:lstStyle /><a:p><a:pPr lvl="0" marL="0" indent="0" algn="l"><a:buNone /></a:pPr><a:r><a:rPr /><a:t>Secondaire</a:t></a:r></a:p></a:txBody></a:tc><a:tc><a:txBody><a:bodyPr /><a:lstStyle /><a:p><a:pPr lvl="0" marL="0" indent="0" algn="l"><a:buNone /></a:pPr><a:r><a:rPr /><a:t>Géométrie</a:t></a:r><a:r><a:rPr /><a:t> </a:t></a:r><a:r><a:rPr /><a:t>avec</a:t></a:r><a:r><a:rPr /><a:t> </a:t></a:r><a:r><a:rPr /><a:t>l’impression</a:t></a:r><a:r><a:rPr /><a:t> </a:t></a:r><a:r><a:rPr /><a:t>3D</a:t></a:r></a:p></a:txBody></a:tc></a:tr><a:tr h="0"><a:tc><a:txBody><a:bodyPr /><a:lstStyle /><a:p><a:pPr lvl="0" marL="0" indent="0" algn="l"><a:buNone /></a:pPr><a:r><a:rPr /><a:t>Supérieur</a:t></a:r></a:p></a:txBody></a:tc><a:tc><a:txBody><a:bodyPr /><a:lstStyle /><a:p><a:pPr lvl="0" marL="0" indent="0" algn="l"><a:buNone /></a:pPr><a:r><a:rPr /><a:t>Le</a:t></a:r><a:r><a:rPr /><a:t> </a:t></a:r><a:r><a:rPr /><a:t>raisonnement</a:t></a:r><a:r><a:rPr /><a:t> </a:t></a:r><a:r><a:rPr /><a:t>mathématique</a:t></a:r><a:r><a:rPr /><a:t> </a:t></a:r><a:r><a:rPr /><a:t>avec</a:t></a:r><a:r><a:rPr /><a:t> </a:t></a:r><a:r><a:rPr /><a:t>L</a:t></a:r><a14:m><m:oMath xmlns:m="http://schemas.openxmlformats.org/officeDocument/2006/math"><m:r><m:t>∃</m:t></m:r><m:r><m:t>∀</m:t></m:r></m:oMath></a14:m><a:r><a:rPr /><a:t>N</a:t></a:r></a:p></a:txBody></a:tc></a:tr></a:tbl></a:graphicData></a:graphic></p:graphicFrame></p:spTree></p:cSld></p:sld>
+<file path=ppt/slides/slide19.xml><?xml version="1.0" encoding="utf-8"?>
+<p:sld xmlns:a="http://schemas.openxmlformats.org/drawingml/2006/main" xmlns:r="http://schemas.openxmlformats.org/officeDocument/2006/relationships" xmlns:p="http://schemas.openxmlformats.org/presentationml/2006/main">
+  <p:cSld>
+    <p:spTree>
+      <p:nvGrpSpPr>
+        <p:cNvPr id="1" name=""/>
+        <p:cNvGrpSpPr/>
+        <p:nvPr/>
+      </p:nvGrpSpPr>
+      <p:grpSpPr>
+        <a:xfrm>
+          <a:off x="0" y="0"/>
+          <a:ext cx="0" cy="0"/>
+          <a:chOff x="0" y="0"/>
+          <a:chExt cx="0" cy="0"/>
+        </a:xfrm>
+      </p:grpSpPr>
+      <p:graphicFrame>
+        <p:nvGraphicFramePr>
+          <p:cNvPr id="6" name="Content Placeholder 5"/>
+          <p:cNvGraphicFramePr>
+            <a:graphicFrameLocks noGrp="1"/>
+          </p:cNvGraphicFramePr>
+          <p:nvPr>
+            <p:ph idx="1"/>
+          </p:nvPr>
+        </p:nvGraphicFramePr>
+        <p:xfrm>
+          <a:off x="457200" y="1600200"/>
+          <a:ext cx="8229600" cy="4521200"/>
+        </p:xfrm>
+        <a:graphic>
+          <a:graphicData uri="http://schemas.openxmlformats.org/drawingml/2006/table">
+            <a:tbl>
+              <a:tblPr firstRow="1" bandRow="1">
+                <a:tableStyleId>{5C22544A-7EE6-4342-B048-85BDC9FD1C3A}</a:tableStyleId>
+              </a:tblPr>
+              <a:tblGrid>
+                <a:gridCol w="4114800"/>
+                <a:gridCol w="4114800"/>
+              </a:tblGrid>
+              <a:tr h="0">
+                <a:tc>
+                  <a:txBody>
+                    <a:bodyPr/>
+                    <a:lstStyle/>
+                    <a:p>
+                      <a:pPr lvl="0" marL="0" indent="0" algn="l">
+                        <a:buNone/>
+                      </a:pPr>
+                      <a:r>
+                        <a:rPr/>
+                        <a:t>Primaire</a:t>
+                      </a:r>
+                    </a:p>
+                  </a:txBody>
+                </a:tc>
+                <a:tc>
+                  <a:txBody>
+                    <a:bodyPr/>
+                    <a:lstStyle/>
+                    <a:p>
+                      <a:pPr lvl="0" marL="0" indent="0" algn="l">
+                        <a:buNone/>
+                      </a:pPr>
+                      <a:r>
+                        <a:rPr/>
+                        <a:t>Nombres</a:t>
+                      </a:r>
+                      <a:r>
+                        <a:rPr/>
+                        <a:t> </a:t>
+                      </a:r>
+                      <a:r>
+                        <a:rPr/>
+                        <a:t>avec</a:t>
+                      </a:r>
+                      <a:r>
+                        <a:rPr/>
+                        <a:t> </a:t>
+                      </a:r>
+                      <a:r>
+                        <a:rPr/>
+                        <a:t>la</a:t>
+                      </a:r>
+                      <a:r>
+                        <a:rPr/>
+                        <a:t> </a:t>
+                      </a:r>
+                      <a:r>
+                        <a:rPr/>
+                        <a:t>yupana</a:t>
+                      </a:r>
+                      <a:r>
+                        <a:rPr/>
+                        <a:t> </a:t>
+                      </a:r>
+                      <a:r>
+                        <a:rPr/>
+                        <a:t>inca</a:t>
+                      </a:r>
+                    </a:p>
+                  </a:txBody>
+                </a:tc>
+              </a:tr>
+              <a:tr h="0">
+                <a:tc>
+                  <a:txBody>
+                    <a:bodyPr/>
+                    <a:lstStyle/>
+                    <a:p>
+                      <a:pPr lvl="0" marL="0" indent="0" algn="l">
+                        <a:buNone/>
+                      </a:pPr>
+                      <a:r>
+                        <a:rPr/>
+                        <a:t>Secondaire</a:t>
+                      </a:r>
+                    </a:p>
+                  </a:txBody>
+                </a:tc>
+                <a:tc>
+                  <a:txBody>
+                    <a:bodyPr/>
+                    <a:lstStyle/>
+                    <a:p>
+                      <a:pPr lvl="0" marL="0" indent="0" algn="l">
+                        <a:buNone/>
+                      </a:pPr>
+                      <a:r>
+                        <a:rPr/>
+                        <a:t>Géométrie</a:t>
+                      </a:r>
+                      <a:r>
+                        <a:rPr/>
+                        <a:t> </a:t>
+                      </a:r>
+                      <a:r>
+                        <a:rPr/>
+                        <a:t>avec</a:t>
+                      </a:r>
+                      <a:r>
+                        <a:rPr/>
+                        <a:t> </a:t>
+                      </a:r>
+                      <a:r>
+                        <a:rPr/>
+                        <a:t>l’impression</a:t>
+                      </a:r>
+                      <a:r>
+                        <a:rPr/>
+                        <a:t> </a:t>
+                      </a:r>
+                      <a:r>
+                        <a:rPr/>
+                        <a:t>3D</a:t>
+                      </a:r>
+                    </a:p>
+                  </a:txBody>
+                </a:tc>
+              </a:tr>
+              <a:tr h="0">
+                <a:tc>
+                  <a:txBody>
+                    <a:bodyPr/>
+                    <a:lstStyle/>
+                    <a:p>
+                      <a:pPr lvl="0" marL="0" indent="0" algn="l">
+                        <a:buNone/>
+                      </a:pPr>
+                      <a:r>
+                        <a:rPr/>
+                        <a:t>Supérieur</a:t>
+                      </a:r>
+                    </a:p>
+                  </a:txBody>
+                </a:tc>
+                <a:tc>
+                  <a:txBody>
+                    <a:bodyPr/>
+                    <a:lstStyle/>
+                    <a:p>
+                      <a:pPr lvl="0" marL="0" indent="0" algn="l">
+                        <a:buNone/>
+                      </a:pPr>
+                      <a:r>
+                        <a:rPr/>
+                        <a:t>Le</a:t>
+                      </a:r>
+                      <a:r>
+                        <a:rPr/>
+                        <a:t> </a:t>
+                      </a:r>
+                      <a:r>
+                        <a:rPr/>
+                        <a:t>raisonnement</a:t>
+                      </a:r>
+                      <a:r>
+                        <a:rPr/>
+                        <a:t> </a:t>
+                      </a:r>
+                      <a:r>
+                        <a:rPr/>
+                        <a:t>mathématique</a:t>
+                      </a:r>
+                      <a:r>
+                        <a:rPr/>
+                        <a:t> </a:t>
+                      </a:r>
+                      <a:r>
+                        <a:rPr/>
+                        <a:t>avec</a:t>
+                      </a:r>
+                      <a:r>
+                        <a:rPr/>
+                        <a:t> </a:t>
+                      </a:r>
+                      <a:r>
+                        <a:rPr/>
+                        <a:t>LEAN</a:t>
+                      </a:r>
+                    </a:p>
+                  </a:txBody>
+                </a:tc>
+              </a:tr>
+            </a:tbl>
+          </a:graphicData>
+        </a:graphic>
+      </p:graphicFrame>
+    </p:spTree>
+  </p:cSld>
+</p:sld>
 </file>
 
 <file path=ppt/slides/slide2.xml><?xml version="1.0" encoding="utf-8"?>
@@ -4851,7 +5073,12 @@
             </a:pPr>
             <a:r>
               <a:rPr/>
-              <a:t>peuvent bénéficier d’une collaboration dans Sfere au-delà de l’ADEF, en particulier avec l’I2M et l’IREM de Marseille.</a:t>
+              <a:t>peuvent bénéficier d’une collaboration dans Sfere au-delà de l’ADEF,</a:t>
+            </a:r>
+            <a:br/>
+            <a:r>
+              <a:rPr/>
+              <a:t>en particulier avec l’I2M et l’IREM de Marseille.</a:t>
             </a:r>
           </a:p>
         </p:txBody>
@@ -4922,7 +5149,7 @@
             </a:pPr>
             <a:r>
               <a:rPr/>
-              <a:t>2015: Médiation scientifique et plateformes de partage</a:t>
+              <a:t>2014: Médiation scientifique et plateformes de partage</a:t>
             </a:r>
             <a:br/>
             <a:r>
@@ -4953,7 +5180,27 @@
             <a:pPr lvl="2"/>
             <a:r>
               <a:rPr/>
-              <a:t>suite d’un projet de Sfere: cartographie de la relation entre l’éducation, la médiation, les expériences artistique et scientifique et le développement de la personne, 2018</a:t>
+              <a:t>suite d’un projet de Sfere: cartographie de la relation entre</a:t>
+            </a:r>
+            <a:br/>
+          </a:p>
+          <a:p>
+            <a:pPr lvl="2">
+              <a:buNone/>
+            </a:pPr>
+            <a:r>
+              <a:rPr/>
+              <a:t>l’éducation, la médiation, les expériences artistique et scientifique</a:t>
+            </a:r>
+            <a:br/>
+          </a:p>
+          <a:p>
+            <a:pPr lvl="2">
+              <a:buNone/>
+            </a:pPr>
+            <a:r>
+              <a:rPr/>
+              <a:t>et le développement de la personne, 2018</a:t>
             </a:r>
           </a:p>
           <a:p>
@@ -4968,15 +5215,6 @@
             <a:r>
               <a:rPr/>
               <a:t>formation à des compétences informatiques pour la recherche.</a:t>
-            </a:r>
-          </a:p>
-          <a:p>
-            <a:pPr lvl="0" marL="0" indent="0">
-              <a:buNone/>
-            </a:pPr>
-            <a:r>
-              <a:rPr/>
-              <a:t>Possible collaboration avec l’IMéRA…</a:t>
             </a:r>
           </a:p>
         </p:txBody>
@@ -5125,7 +5363,7 @@
             </a:pPr>
             <a:r>
               <a:rPr/>
-              <a:t>Une autre exposition Imaginary à Marseille</a:t>
+              <a:t>Une nouvelle exposition Imaginary à Marseille</a:t>
             </a:r>
             <a:br/>
             <a:r>
@@ -5380,6 +5618,35 @@
                         <a:rPr/>
                         <a:t>«maker»</a:t>
                       </a:r>
+                    </a:p>
+                  </a:txBody>
+                </a:tc>
+              </a:tr>
+              <a:tr h="0">
+                <a:tc>
+                  <a:txBody>
+                    <a:bodyPr/>
+                    <a:lstStyle/>
+                    <a:p>
+                      <a:endParaRPr/>
+                    </a:p>
+                  </a:txBody>
+                </a:tc>
+                <a:tc>
+                  <a:txBody>
+                    <a:bodyPr/>
+                    <a:lstStyle/>
+                    <a:p>
+                      <a:endParaRPr/>
+                    </a:p>
+                  </a:txBody>
+                </a:tc>
+                <a:tc>
+                  <a:txBody>
+                    <a:bodyPr/>
+                    <a:lstStyle/>
+                    <a:p>
+                      <a:endParaRPr/>
                     </a:p>
                   </a:txBody>
                 </a:tc>
@@ -5595,8 +5862,238 @@
 </p:sld>
 </file>
 
-<file path=ppt/slides/slide3.xml><?xml version="1.0" encoding="UTF-8"?>
-<p:sld xmlns:a="http://schemas.openxmlformats.org/drawingml/2006/main" xmlns:r="http://schemas.openxmlformats.org/officeDocument/2006/relationships" xmlns:p="http://schemas.openxmlformats.org/presentationml/2006/main"><p:cSld><p:spTree><p:nvGrpSpPr><p:cNvPr id="1" name="" /><p:cNvGrpSpPr /><p:nvPr /></p:nvGrpSpPr><p:grpSpPr><a:xfrm><a:off x="0" y="0" /><a:ext cx="0" cy="0" /><a:chOff x="0" y="0" /><a:chExt cx="0" cy="0" /></a:xfrm></p:grpSpPr><p:graphicFrame><p:nvGraphicFramePr><p:cNvPr id="6" name="Content Placeholder 5" /><p:cNvGraphicFramePr><a:graphicFrameLocks noGrp="1" /></p:cNvGraphicFramePr><p:nvPr><p:ph idx="1" /></p:nvPr></p:nvGraphicFramePr><p:xfrm><a:off x="457200" y="1600200" /><a:ext cx="8229600" cy="4521200" /></p:xfrm><a:graphic><a:graphicData uri="http://schemas.openxmlformats.org/drawingml/2006/table"><a:tbl><a:tblPr firstRow="1" bandRow="1"><a:tableStyleId>{5C22544A-7EE6-4342-B048-85BDC9FD1C3A}</a:tableStyleId></a:tblPr><a:tblGrid><a:gridCol w="4114800" /><a:gridCol w="4114800" /></a:tblGrid><a:tr h="0"><a:tc><a:txBody><a:bodyPr /><a:lstStyle /><a:p><a:pPr lvl="0" marL="0" indent="0" algn="l"><a:buNone /></a:pPr><a:r><a:rPr /><a:t>Primaire</a:t></a:r></a:p></a:txBody></a:tc><a:tc><a:txBody><a:bodyPr /><a:lstStyle /><a:p><a:pPr lvl="0" marL="0" indent="0" algn="l"><a:buNone /></a:pPr><a:r><a:rPr /><a:t>Nombres</a:t></a:r><a:r><a:rPr /><a:t> </a:t></a:r><a:r><a:rPr /><a:t>avec</a:t></a:r><a:r><a:rPr /><a:t> </a:t></a:r><a:r><a:rPr /><a:t>la</a:t></a:r><a:r><a:rPr /><a:t> </a:t></a:r><a:r><a:rPr /><a:t>yupana</a:t></a:r><a:r><a:rPr /><a:t> </a:t></a:r><a:r><a:rPr /><a:t>inca</a:t></a:r></a:p></a:txBody></a:tc></a:tr><a:tr h="0"><a:tc><a:txBody><a:bodyPr /><a:lstStyle /><a:p><a:pPr lvl="0" marL="0" indent="0" algn="l"><a:buNone /></a:pPr><a:r><a:rPr /><a:t>Secondaire</a:t></a:r></a:p></a:txBody></a:tc><a:tc><a:txBody><a:bodyPr /><a:lstStyle /><a:p><a:pPr lvl="0" marL="0" indent="0" algn="l"><a:buNone /></a:pPr><a:r><a:rPr /><a:t>Géométrie</a:t></a:r><a:r><a:rPr /><a:t> </a:t></a:r><a:r><a:rPr /><a:t>avec</a:t></a:r><a:r><a:rPr /><a:t> </a:t></a:r><a:r><a:rPr /><a:t>l’impression</a:t></a:r><a:r><a:rPr /><a:t> </a:t></a:r><a:r><a:rPr /><a:t>3D</a:t></a:r></a:p></a:txBody></a:tc></a:tr><a:tr h="0"><a:tc><a:txBody><a:bodyPr /><a:lstStyle /><a:p><a:pPr lvl="0" marL="0" indent="0" algn="l"><a:buNone /></a:pPr><a:r><a:rPr /><a:t>Supérieur</a:t></a:r></a:p></a:txBody></a:tc><a:tc><a:txBody><a:bodyPr /><a:lstStyle /><a:p><a:pPr lvl="0" marL="0" indent="0" algn="l"><a:buNone /></a:pPr><a:r><a:rPr /><a:t>Le</a:t></a:r><a:r><a:rPr /><a:t> </a:t></a:r><a:r><a:rPr /><a:t>raisonnement</a:t></a:r><a:r><a:rPr /><a:t> </a:t></a:r><a:r><a:rPr /><a:t>mathématique</a:t></a:r><a:r><a:rPr /><a:t> </a:t></a:r><a:r><a:rPr /><a:t>avec</a:t></a:r><a:r><a:rPr /><a:t> </a:t></a:r><a:r><a:rPr /><a:t>L</a:t></a:r><a14:m><m:oMath xmlns:m="http://schemas.openxmlformats.org/officeDocument/2006/math"><m:r><m:t>∃</m:t></m:r><m:r><m:t>∀</m:t></m:r></m:oMath></a14:m><a:r><a:rPr /><a:t>N</a:t></a:r></a:p></a:txBody></a:tc></a:tr></a:tbl></a:graphicData></a:graphic></p:graphicFrame></p:spTree></p:cSld></p:sld>
+<file path=ppt/slides/slide3.xml><?xml version="1.0" encoding="utf-8"?>
+<p:sld xmlns:a="http://schemas.openxmlformats.org/drawingml/2006/main" xmlns:r="http://schemas.openxmlformats.org/officeDocument/2006/relationships" xmlns:p="http://schemas.openxmlformats.org/presentationml/2006/main">
+  <p:cSld>
+    <p:spTree>
+      <p:nvGrpSpPr>
+        <p:cNvPr id="1" name=""/>
+        <p:cNvGrpSpPr/>
+        <p:nvPr/>
+      </p:nvGrpSpPr>
+      <p:grpSpPr>
+        <a:xfrm>
+          <a:off x="0" y="0"/>
+          <a:ext cx="0" cy="0"/>
+          <a:chOff x="0" y="0"/>
+          <a:chExt cx="0" cy="0"/>
+        </a:xfrm>
+      </p:grpSpPr>
+      <p:graphicFrame>
+        <p:nvGraphicFramePr>
+          <p:cNvPr id="6" name="Content Placeholder 5"/>
+          <p:cNvGraphicFramePr>
+            <a:graphicFrameLocks noGrp="1"/>
+          </p:cNvGraphicFramePr>
+          <p:nvPr>
+            <p:ph idx="1"/>
+          </p:nvPr>
+        </p:nvGraphicFramePr>
+        <p:xfrm>
+          <a:off x="457200" y="1600200"/>
+          <a:ext cx="8229600" cy="4521200"/>
+        </p:xfrm>
+        <a:graphic>
+          <a:graphicData uri="http://schemas.openxmlformats.org/drawingml/2006/table">
+            <a:tbl>
+              <a:tblPr firstRow="1" bandRow="1">
+                <a:tableStyleId>{5C22544A-7EE6-4342-B048-85BDC9FD1C3A}</a:tableStyleId>
+              </a:tblPr>
+              <a:tblGrid>
+                <a:gridCol w="4114800"/>
+                <a:gridCol w="4114800"/>
+              </a:tblGrid>
+              <a:tr h="0">
+                <a:tc>
+                  <a:txBody>
+                    <a:bodyPr/>
+                    <a:lstStyle/>
+                    <a:p>
+                      <a:pPr lvl="0" marL="0" indent="0" algn="l">
+                        <a:buNone/>
+                      </a:pPr>
+                      <a:r>
+                        <a:rPr/>
+                        <a:t>Primaire</a:t>
+                      </a:r>
+                    </a:p>
+                  </a:txBody>
+                </a:tc>
+                <a:tc>
+                  <a:txBody>
+                    <a:bodyPr/>
+                    <a:lstStyle/>
+                    <a:p>
+                      <a:pPr lvl="0" marL="0" indent="0" algn="l">
+                        <a:buNone/>
+                      </a:pPr>
+                      <a:r>
+                        <a:rPr/>
+                        <a:t>Nombres</a:t>
+                      </a:r>
+                      <a:r>
+                        <a:rPr/>
+                        <a:t> </a:t>
+                      </a:r>
+                      <a:r>
+                        <a:rPr/>
+                        <a:t>avec</a:t>
+                      </a:r>
+                      <a:r>
+                        <a:rPr/>
+                        <a:t> </a:t>
+                      </a:r>
+                      <a:r>
+                        <a:rPr/>
+                        <a:t>la</a:t>
+                      </a:r>
+                      <a:r>
+                        <a:rPr/>
+                        <a:t> </a:t>
+                      </a:r>
+                      <a:r>
+                        <a:rPr/>
+                        <a:t>yupana</a:t>
+                      </a:r>
+                      <a:r>
+                        <a:rPr/>
+                        <a:t> </a:t>
+                      </a:r>
+                      <a:r>
+                        <a:rPr/>
+                        <a:t>inca</a:t>
+                      </a:r>
+                    </a:p>
+                  </a:txBody>
+                </a:tc>
+              </a:tr>
+              <a:tr h="0">
+                <a:tc>
+                  <a:txBody>
+                    <a:bodyPr/>
+                    <a:lstStyle/>
+                    <a:p>
+                      <a:pPr lvl="0" marL="0" indent="0" algn="l">
+                        <a:buNone/>
+                      </a:pPr>
+                      <a:r>
+                        <a:rPr/>
+                        <a:t>Secondaire</a:t>
+                      </a:r>
+                    </a:p>
+                  </a:txBody>
+                </a:tc>
+                <a:tc>
+                  <a:txBody>
+                    <a:bodyPr/>
+                    <a:lstStyle/>
+                    <a:p>
+                      <a:pPr lvl="0" marL="0" indent="0" algn="l">
+                        <a:buNone/>
+                      </a:pPr>
+                      <a:r>
+                        <a:rPr/>
+                        <a:t>Géométrie</a:t>
+                      </a:r>
+                      <a:r>
+                        <a:rPr/>
+                        <a:t> </a:t>
+                      </a:r>
+                      <a:r>
+                        <a:rPr/>
+                        <a:t>avec</a:t>
+                      </a:r>
+                      <a:r>
+                        <a:rPr/>
+                        <a:t> </a:t>
+                      </a:r>
+                      <a:r>
+                        <a:rPr/>
+                        <a:t>l’impression</a:t>
+                      </a:r>
+                      <a:r>
+                        <a:rPr/>
+                        <a:t> </a:t>
+                      </a:r>
+                      <a:r>
+                        <a:rPr/>
+                        <a:t>3D</a:t>
+                      </a:r>
+                    </a:p>
+                  </a:txBody>
+                </a:tc>
+              </a:tr>
+              <a:tr h="0">
+                <a:tc>
+                  <a:txBody>
+                    <a:bodyPr/>
+                    <a:lstStyle/>
+                    <a:p>
+                      <a:pPr lvl="0" marL="0" indent="0" algn="l">
+                        <a:buNone/>
+                      </a:pPr>
+                      <a:r>
+                        <a:rPr/>
+                        <a:t>Supérieur</a:t>
+                      </a:r>
+                    </a:p>
+                  </a:txBody>
+                </a:tc>
+                <a:tc>
+                  <a:txBody>
+                    <a:bodyPr/>
+                    <a:lstStyle/>
+                    <a:p>
+                      <a:pPr lvl="0" marL="0" indent="0" algn="l">
+                        <a:buNone/>
+                      </a:pPr>
+                      <a:r>
+                        <a:rPr/>
+                        <a:t>Le</a:t>
+                      </a:r>
+                      <a:r>
+                        <a:rPr/>
+                        <a:t> </a:t>
+                      </a:r>
+                      <a:r>
+                        <a:rPr/>
+                        <a:t>raisonnement</a:t>
+                      </a:r>
+                      <a:r>
+                        <a:rPr/>
+                        <a:t> </a:t>
+                      </a:r>
+                      <a:r>
+                        <a:rPr/>
+                        <a:t>mathématique</a:t>
+                      </a:r>
+                      <a:r>
+                        <a:rPr/>
+                        <a:t> </a:t>
+                      </a:r>
+                      <a:r>
+                        <a:rPr/>
+                        <a:t>avec</a:t>
+                      </a:r>
+                      <a:r>
+                        <a:rPr/>
+                        <a:t> </a:t>
+                      </a:r>
+                      <a:r>
+                        <a:rPr/>
+                        <a:t>LEAN</a:t>
+                      </a:r>
+                    </a:p>
+                  </a:txBody>
+                </a:tc>
+              </a:tr>
+            </a:tbl>
+          </a:graphicData>
+        </a:graphic>
+      </p:graphicFrame>
+    </p:spTree>
+  </p:cSld>
+</p:sld>
 </file>
 
 <file path=ppt/slides/slide4.xml><?xml version="1.0" encoding="utf-8"?>
@@ -5653,7 +6150,7 @@
             </a:pPr>
             <a:r>
               <a:rPr/>
-              <a:t>Expérience d’initiation à l’addition et à la multiplication</a:t>
+              <a:t>Initiation à l’addition et à la multiplication</a:t>
             </a:r>
           </a:p>
         </p:txBody>
@@ -5703,7 +6200,7 @@
             </a:pPr>
             <a:r>
               <a:rPr b="1"/>
-              <a:t>L’impression 3D</a:t>
+              <a:t>Impression 3D</a:t>
             </a:r>
           </a:p>
           <a:p>
@@ -5717,7 +6214,7 @@
             </a:pPr>
             <a:r>
               <a:rPr/>
-              <a:t>Vecteur de compréhension de la géométrie.</a:t>
+              <a:t>Vecteur de compréhension de la géométrie</a:t>
             </a:r>
           </a:p>
         </p:txBody>
@@ -5767,7 +6264,7 @@
             </a:pPr>
             <a:r>
               <a:rPr b="1"/>
-              <a:t>L’impression 3D</a:t>
+              <a:t>Impression 3D</a:t>
             </a:r>
           </a:p>
         </p:txBody>
@@ -5918,21 +6415,7 @@
                 </a:pPr>
                 <a:r>
                   <a:rPr b="1"/>
-                  <a:t>Le raisonnement mathématique avec L</a:t>
-                </a:r>
-                <a14:m>
-                  <m:oMath xmlns:m="http://schemas.openxmlformats.org/officeDocument/2006/math">
-                    <m:r>
-                      <m:t>∃</m:t>
-                    </m:r>
-                    <m:r>
-                      <m:t>∀</m:t>
-                    </m:r>
-                  </m:oMath>
-                </a14:m>
-                <a:r>
-                  <a:rPr b="1"/>
-                  <a:t>N</a:t>
+                  <a:t>Raisonnement mathématique avec LEAN</a:t>
                 </a:r>
               </a:p>
               <a:p>
@@ -5941,7 +6424,7 @@
                 </a:pPr>
                 <a:r>
                   <a:rPr/>
-                  <a:t>L</a:t>
+                  <a:t>LEAN: un assistant de preuves (L</a:t>
                 </a:r>
                 <a14:m>
                   <m:oMath xmlns:m="http://schemas.openxmlformats.org/officeDocument/2006/math">
@@ -5955,7 +6438,7 @@
                 </a14:m>
                 <a:r>
                   <a:rPr/>
-                  <a:t>N: un assistant de preuves (LEAN)</a:t>
+                  <a:t>N)</a:t>
                 </a:r>
               </a:p>
               <a:p>
@@ -5981,7 +6464,7 @@
                 <a:br/>
                 <a:r>
                   <a:rPr/>
-                  <a:t>prof d’université en mathématiques à Orsay</a:t>
+                  <a:t>professeur en mathématiques à Orsay</a:t>
                 </a:r>
               </a:p>
               <a:p>
@@ -5995,7 +6478,7 @@
                 </a:pPr>
                 <a:r>
                   <a:rPr/>
-                  <a:t>Exemple de démonstration rédigée sur papier</a:t>
+                  <a:t>Démonstration rédigée sur papier</a:t>
                 </a:r>
               </a:p>
             </p:txBody>

</xml_diff>